<commit_message>
Update demo presentation (v2).
- Replace diagram boxes with actual code blocks (monospace)
- Fill slide 2 with real AdcDsp.vhd code
- Fill slide 3 with actual prompt text in terminal style
- AGENTS.md slide uses one large code block with more content
- Implementation output uses path hierarchy layout
- Review slide uses Claude terminal style boxes
- Added note about underspecified software prompting

Co-Authored-By: Claude Opus 4.6 (1M context) <noreply@anthropic.com>
</commit_message>
<xml_diff>
--- a/docs/plans/fp-dsp-pid/ECC_AI_Demo_Use_Case_2.pptx
+++ b/docs/plans/fp-dsp-pid/ECC_AI_Demo_Use_Case_2.pptx
@@ -40883,52 +40883,351 @@
           </a:fontRef>
         </p:style>
         <p:txBody>
-          <a:bodyPr rtlCol="0" anchor="ctr" wrap="square" lIns="150000" tIns="100000"/>
+          <a:bodyPr rtlCol="0" anchor="ctr" wrap="square" lIns="150000" tIns="100000" rIns="150000"/>
           <a:lstStyle/>
           <a:p>
             <a:pPr algn="ctr">
-              <a:defRPr sz="1000">
-                <a:solidFill>
-                  <a:srgbClr val="4EC9B0"/>
+              <a:defRPr sz="900">
+                <a:solidFill>
+                  <a:srgbClr val="888899"/>
                 </a:solidFill>
                 <a:latin typeface="Courier New"/>
               </a:defRPr>
             </a:pPr>
             <a:r>
-              <a:t>[Screenshot: AdcDsp.vhd — existing fixed-point PID]</a:t>
+              <a:t>── AdcDsp.vhd (existing fixed-point) ──</a:t>
             </a:r>
-            <a:br/>
-            <a:br/>
+          </a:p>
+          <a:p>
+            <a:pPr>
+              <a:defRPr sz="1000">
+                <a:solidFill>
+                  <a:srgbClr val="D4D4D4"/>
+                </a:solidFill>
+                <a:latin typeface="Courier New"/>
+              </a:defRPr>
+            </a:pPr>
             <a:r>
-              <a:t>PID_P_S:</a:t>
+              <a:t>when PID_P_S =&gt;</a:t>
             </a:r>
-            <a:br/>
+          </a:p>
+          <a:p>
+            <a:pPr>
+              <a:defRPr sz="1000">
+                <a:solidFill>
+                  <a:srgbClr val="D4D4D4"/>
+                </a:solidFill>
+                <a:latin typeface="Courier New"/>
+              </a:defRPr>
+            </a:pPr>
             <a:r>
               <a:t>  v.pidResult := resize(</a:t>
             </a:r>
-            <a:br/>
+          </a:p>
+          <a:p>
+            <a:pPr>
+              <a:defRPr sz="1000">
+                <a:solidFill>
+                  <a:srgbClr val="D4D4D4"/>
+                </a:solidFill>
+                <a:latin typeface="Courier New"/>
+              </a:defRPr>
+            </a:pPr>
             <a:r>
               <a:t>    r.pidResult +</a:t>
             </a:r>
-            <a:br/>
+          </a:p>
+          <a:p>
+            <a:pPr>
+              <a:defRPr sz="1000">
+                <a:solidFill>
+                  <a:srgbClr val="D4D4D4"/>
+                </a:solidFill>
+                <a:latin typeface="Courier New"/>
+              </a:defRPr>
+            </a:pPr>
             <a:r>
               <a:t>    (r.pidCoef * r.pidMultiplier),</a:t>
             </a:r>
-            <a:br/>
+          </a:p>
+          <a:p>
+            <a:pPr>
+              <a:defRPr sz="1000">
+                <a:solidFill>
+                  <a:srgbClr val="D4D4D4"/>
+                </a:solidFill>
+                <a:latin typeface="Courier New"/>
+              </a:defRPr>
+            </a:pPr>
             <a:r>
               <a:t>    v.pidResult);</a:t>
             </a:r>
-            <a:br/>
+          </a:p>
+          <a:p>
+            <a:pPr>
+              <a:defRPr sz="1000">
+                <a:solidFill>
+                  <a:srgbClr val="D4D4D4"/>
+                </a:solidFill>
+                <a:latin typeface="Courier New"/>
+              </a:defRPr>
+            </a:pPr>
             <a:r>
-              <a:t>  v.pidCoef := iSfixed;</a:t>
+              <a:t>  v.pidCoef       := iSfixed;</a:t>
             </a:r>
-            <a:br/>
+          </a:p>
+          <a:p>
+            <a:pPr>
+              <a:defRPr sz="1000">
+                <a:solidFill>
+                  <a:srgbClr val="D4D4D4"/>
+                </a:solidFill>
+                <a:latin typeface="Courier New"/>
+              </a:defRPr>
+            </a:pPr>
             <a:r>
               <a:t>  v.pidMultiplier := r.sumAccum;</a:t>
             </a:r>
-            <a:br/>
+          </a:p>
+          <a:p>
+            <a:pPr>
+              <a:defRPr sz="1000">
+                <a:solidFill>
+                  <a:srgbClr val="D4D4D4"/>
+                </a:solidFill>
+                <a:latin typeface="Courier New"/>
+              </a:defRPr>
+            </a:pPr>
             <a:r>
-              <a:t>  v.state := PID_I_S;</a:t>
+              <a:t>  v.state         := PID_I_S;</a:t>
+            </a:r>
+          </a:p>
+          <a:p>
+            <a:pPr>
+              <a:defRPr sz="1000">
+                <a:solidFill>
+                  <a:srgbClr val="D4D4D4"/>
+                </a:solidFill>
+                <a:latin typeface="Courier New"/>
+              </a:defRPr>
+            </a:pPr>
+          </a:p>
+          <a:p>
+            <a:pPr>
+              <a:defRPr sz="1000">
+                <a:solidFill>
+                  <a:srgbClr val="D4D4D4"/>
+                </a:solidFill>
+                <a:latin typeface="Courier New"/>
+              </a:defRPr>
+            </a:pPr>
+            <a:r>
+              <a:t>when PID_I_S =&gt;</a:t>
+            </a:r>
+          </a:p>
+          <a:p>
+            <a:pPr>
+              <a:defRPr sz="1000">
+                <a:solidFill>
+                  <a:srgbClr val="D4D4D4"/>
+                </a:solidFill>
+                <a:latin typeface="Courier New"/>
+              </a:defRPr>
+            </a:pPr>
+            <a:r>
+              <a:t>  v.pidResult := resize(</a:t>
+            </a:r>
+          </a:p>
+          <a:p>
+            <a:pPr>
+              <a:defRPr sz="1000">
+                <a:solidFill>
+                  <a:srgbClr val="D4D4D4"/>
+                </a:solidFill>
+                <a:latin typeface="Courier New"/>
+              </a:defRPr>
+            </a:pPr>
+            <a:r>
+              <a:t>    r.pidResult +</a:t>
+            </a:r>
+          </a:p>
+          <a:p>
+            <a:pPr>
+              <a:defRPr sz="1000">
+                <a:solidFill>
+                  <a:srgbClr val="D4D4D4"/>
+                </a:solidFill>
+                <a:latin typeface="Courier New"/>
+              </a:defRPr>
+            </a:pPr>
+            <a:r>
+              <a:t>    (r.pidCoef * r.pidMultiplier),</a:t>
+            </a:r>
+          </a:p>
+          <a:p>
+            <a:pPr>
+              <a:defRPr sz="1000">
+                <a:solidFill>
+                  <a:srgbClr val="D4D4D4"/>
+                </a:solidFill>
+                <a:latin typeface="Courier New"/>
+              </a:defRPr>
+            </a:pPr>
+            <a:r>
+              <a:t>    v.pidResult);</a:t>
+            </a:r>
+          </a:p>
+          <a:p>
+            <a:pPr>
+              <a:defRPr sz="1000">
+                <a:solidFill>
+                  <a:srgbClr val="D4D4D4"/>
+                </a:solidFill>
+                <a:latin typeface="Courier New"/>
+              </a:defRPr>
+            </a:pPr>
+            <a:r>
+              <a:t>  v.pidCoef       := dSfixed;</a:t>
+            </a:r>
+          </a:p>
+          <a:p>
+            <a:pPr>
+              <a:defRPr sz="1000">
+                <a:solidFill>
+                  <a:srgbClr val="D4D4D4"/>
+                </a:solidFill>
+                <a:latin typeface="Courier New"/>
+              </a:defRPr>
+            </a:pPr>
+            <a:r>
+              <a:t>  v.pidMultiplier := resize(</a:t>
+            </a:r>
+          </a:p>
+          <a:p>
+            <a:pPr>
+              <a:defRPr sz="1000">
+                <a:solidFill>
+                  <a:srgbClr val="D4D4D4"/>
+                </a:solidFill>
+                <a:latin typeface="Courier New"/>
+              </a:defRPr>
+            </a:pPr>
+            <a:r>
+              <a:t>    r.lastAccumError - r.accumError,</a:t>
+            </a:r>
+          </a:p>
+          <a:p>
+            <a:pPr>
+              <a:defRPr sz="1000">
+                <a:solidFill>
+                  <a:srgbClr val="D4D4D4"/>
+                </a:solidFill>
+                <a:latin typeface="Courier New"/>
+              </a:defRPr>
+            </a:pPr>
+            <a:r>
+              <a:t>    v.pidMultiplier);</a:t>
+            </a:r>
+          </a:p>
+          <a:p>
+            <a:pPr>
+              <a:defRPr sz="1000">
+                <a:solidFill>
+                  <a:srgbClr val="D4D4D4"/>
+                </a:solidFill>
+                <a:latin typeface="Courier New"/>
+              </a:defRPr>
+            </a:pPr>
+            <a:r>
+              <a:t>  v.state         := PID_D_S;</a:t>
+            </a:r>
+          </a:p>
+          <a:p>
+            <a:pPr>
+              <a:defRPr sz="1000">
+                <a:solidFill>
+                  <a:srgbClr val="D4D4D4"/>
+                </a:solidFill>
+                <a:latin typeface="Courier New"/>
+              </a:defRPr>
+            </a:pPr>
+          </a:p>
+          <a:p>
+            <a:pPr>
+              <a:defRPr sz="1000">
+                <a:solidFill>
+                  <a:srgbClr val="D4D4D4"/>
+                </a:solidFill>
+                <a:latin typeface="Courier New"/>
+              </a:defRPr>
+            </a:pPr>
+            <a:r>
+              <a:t>when PID_D_S =&gt;</a:t>
+            </a:r>
+          </a:p>
+          <a:p>
+            <a:pPr>
+              <a:defRPr sz="1000">
+                <a:solidFill>
+                  <a:srgbClr val="D4D4D4"/>
+                </a:solidFill>
+                <a:latin typeface="Courier New"/>
+              </a:defRPr>
+            </a:pPr>
+            <a:r>
+              <a:t>  pidResultNext := resize(</a:t>
+            </a:r>
+          </a:p>
+          <a:p>
+            <a:pPr>
+              <a:defRPr sz="1000">
+                <a:solidFill>
+                  <a:srgbClr val="D4D4D4"/>
+                </a:solidFill>
+                <a:latin typeface="Courier New"/>
+              </a:defRPr>
+            </a:pPr>
+            <a:r>
+              <a:t>    r.pidResult +</a:t>
+            </a:r>
+          </a:p>
+          <a:p>
+            <a:pPr>
+              <a:defRPr sz="1000">
+                <a:solidFill>
+                  <a:srgbClr val="D4D4D4"/>
+                </a:solidFill>
+                <a:latin typeface="Courier New"/>
+              </a:defRPr>
+            </a:pPr>
+            <a:r>
+              <a:t>    (r.pidCoef * r.pidMultiplier),</a:t>
+            </a:r>
+          </a:p>
+          <a:p>
+            <a:pPr>
+              <a:defRPr sz="1000">
+                <a:solidFill>
+                  <a:srgbClr val="D4D4D4"/>
+                </a:solidFill>
+                <a:latin typeface="Courier New"/>
+              </a:defRPr>
+            </a:pPr>
+            <a:r>
+              <a:t>    pidResultNext);</a:t>
+            </a:r>
+          </a:p>
+          <a:p>
+            <a:pPr>
+              <a:defRPr sz="1000">
+                <a:solidFill>
+                  <a:srgbClr val="D4D4D4"/>
+                </a:solidFill>
+                <a:latin typeface="Courier New"/>
+              </a:defRPr>
+            </a:pPr>
+            <a:r>
+              <a:t>  v.pidResult := pidResultNext;</a:t>
             </a:r>
           </a:p>
         </p:txBody>
@@ -41218,58 +41517,322 @@
           </a:fontRef>
         </p:style>
         <p:txBody>
-          <a:bodyPr rtlCol="0" anchor="ctr" wrap="square" lIns="150000" tIns="100000"/>
+          <a:bodyPr rtlCol="0" anchor="ctr" wrap="square" lIns="150000" tIns="100000" rIns="150000"/>
           <a:lstStyle/>
           <a:p>
             <a:pPr algn="ctr">
-              <a:defRPr sz="1000">
-                <a:solidFill>
-                  <a:srgbClr val="4EC9B0"/>
+              <a:defRPr sz="900">
+                <a:solidFill>
+                  <a:srgbClr val="888899"/>
                 </a:solidFill>
                 <a:latin typeface="Courier New"/>
               </a:defRPr>
             </a:pPr>
             <a:r>
-              <a:t>[Screenshot: Terminal showing initial prompt]</a:t>
+              <a:t>── claude ──</a:t>
             </a:r>
-            <a:br/>
-            <a:br/>
+          </a:p>
+          <a:p>
+            <a:pPr>
+              <a:defRPr sz="1000">
+                <a:solidFill>
+                  <a:srgbClr val="D4D4D4"/>
+                </a:solidFill>
+                <a:latin typeface="Courier New"/>
+              </a:defRPr>
+            </a:pPr>
             <a:r>
-              <a:t>$ claude</a:t>
+              <a:t>╭─────────────────────────────────────────╮</a:t>
             </a:r>
-            <a:br/>
-            <a:br/>
+          </a:p>
+          <a:p>
+            <a:pPr>
+              <a:defRPr sz="1000">
+                <a:solidFill>
+                  <a:srgbClr val="D4D4D4"/>
+                </a:solidFill>
+                <a:latin typeface="Courier New"/>
+              </a:defRPr>
+            </a:pPr>
             <a:r>
-              <a:t>&gt; Let's focus on the</a:t>
+              <a:t>│ &gt; Let's focus on the                    │</a:t>
             </a:r>
-            <a:br/>
+          </a:p>
+          <a:p>
+            <a:pPr>
+              <a:defRPr sz="1000">
+                <a:solidFill>
+                  <a:srgbClr val="D4D4D4"/>
+                </a:solidFill>
+                <a:latin typeface="Courier New"/>
+              </a:defRPr>
+            </a:pPr>
             <a:r>
-              <a:t>&gt; ColumnFpgaBoard325Coordinator10G target.</a:t>
+              <a:t>│   ColumnFpgaBoard325Coordinator10G      │</a:t>
             </a:r>
-            <a:br/>
+          </a:p>
+          <a:p>
+            <a:pPr>
+              <a:defRPr sz="1000">
+                <a:solidFill>
+                  <a:srgbClr val="D4D4D4"/>
+                </a:solidFill>
+                <a:latin typeface="Courier New"/>
+              </a:defRPr>
+            </a:pPr>
             <a:r>
-              <a:t>&gt; The AdcDsp block implements a fixed-point</a:t>
+              <a:t>│   target. In the data path, there is    │</a:t>
             </a:r>
-            <a:br/>
+          </a:p>
+          <a:p>
+            <a:pPr>
+              <a:defRPr sz="1000">
+                <a:solidFill>
+                  <a:srgbClr val="D4D4D4"/>
+                </a:solidFill>
+                <a:latin typeface="Courier New"/>
+              </a:defRPr>
+            </a:pPr>
             <a:r>
-              <a:t>&gt; PID. I'd like to adapt it to use floating</a:t>
+              <a:t>│   a AdcDsp.vhd block that implements    │</a:t>
             </a:r>
-            <a:br/>
+          </a:p>
+          <a:p>
+            <a:pPr>
+              <a:defRPr sz="1000">
+                <a:solidFill>
+                  <a:srgbClr val="D4D4D4"/>
+                </a:solidFill>
+                <a:latin typeface="Courier New"/>
+              </a:defRPr>
+            </a:pPr>
             <a:r>
-              <a:t>&gt; point math. The design already has some FP</a:t>
+              <a:t>│   a fixed point PID calculation. I'd    │</a:t>
             </a:r>
-            <a:br/>
+          </a:p>
+          <a:p>
+            <a:pPr>
+              <a:defRPr sz="1000">
+                <a:solidFill>
+                  <a:srgbClr val="D4D4D4"/>
+                </a:solidFill>
+                <a:latin typeface="Courier New"/>
+              </a:defRPr>
+            </a:pPr>
             <a:r>
-              <a:t>&gt; IP cores. Make a plan.</a:t>
+              <a:t>│   like to adapt this module to use      │</a:t>
             </a:r>
-            <a:br/>
-            <a:br/>
+          </a:p>
+          <a:p>
+            <a:pPr>
+              <a:defRPr sz="1000">
+                <a:solidFill>
+                  <a:srgbClr val="D4D4D4"/>
+                </a:solidFill>
+                <a:latin typeface="Courier New"/>
+              </a:defRPr>
+            </a:pPr>
+            <a:r>
+              <a:t>│   floating point math for the PID       │</a:t>
+            </a:r>
+          </a:p>
+          <a:p>
+            <a:pPr>
+              <a:defRPr sz="1000">
+                <a:solidFill>
+                  <a:srgbClr val="D4D4D4"/>
+                </a:solidFill>
+                <a:latin typeface="Courier New"/>
+              </a:defRPr>
+            </a:pPr>
+            <a:r>
+              <a:t>│   calculation. The design already has   │</a:t>
+            </a:r>
+          </a:p>
+          <a:p>
+            <a:pPr>
+              <a:defRPr sz="1000">
+                <a:solidFill>
+                  <a:srgbClr val="D4D4D4"/>
+                </a:solidFill>
+                <a:latin typeface="Courier New"/>
+              </a:defRPr>
+            </a:pPr>
+            <a:r>
+              <a:t>│   some floating point math happening    │</a:t>
+            </a:r>
+          </a:p>
+          <a:p>
+            <a:pPr>
+              <a:defRPr sz="1000">
+                <a:solidFill>
+                  <a:srgbClr val="D4D4D4"/>
+                </a:solidFill>
+                <a:latin typeface="Courier New"/>
+              </a:defRPr>
+            </a:pPr>
+            <a:r>
+              <a:t>│   in it, and a few Vivado IP cores are  │</a:t>
+            </a:r>
+          </a:p>
+          <a:p>
+            <a:pPr>
+              <a:defRPr sz="1000">
+                <a:solidFill>
+                  <a:srgbClr val="D4D4D4"/>
+                </a:solidFill>
+                <a:latin typeface="Courier New"/>
+              </a:defRPr>
+            </a:pPr>
+            <a:r>
+              <a:t>│   utilized for this. Let's make a plan. │</a:t>
+            </a:r>
+          </a:p>
+          <a:p>
+            <a:pPr>
+              <a:defRPr sz="1000">
+                <a:solidFill>
+                  <a:srgbClr val="D4D4D4"/>
+                </a:solidFill>
+                <a:latin typeface="Courier New"/>
+              </a:defRPr>
+            </a:pPr>
+            <a:r>
+              <a:t>╰─────────────────────────────────────────╯</a:t>
+            </a:r>
+          </a:p>
+          <a:p>
+            <a:pPr>
+              <a:defRPr sz="1000">
+                <a:solidFill>
+                  <a:srgbClr val="D4D4D4"/>
+                </a:solidFill>
+                <a:latin typeface="Courier New"/>
+              </a:defRPr>
+            </a:pPr>
+          </a:p>
+          <a:p>
+            <a:pPr>
+              <a:defRPr sz="1000">
+                <a:solidFill>
+                  <a:srgbClr val="D4D4D4"/>
+                </a:solidFill>
+                <a:latin typeface="Courier New"/>
+              </a:defRPr>
+            </a:pPr>
             <a:r>
               <a:t>I'll explore the codebase to understand the</a:t>
             </a:r>
-            <a:br/>
+          </a:p>
+          <a:p>
+            <a:pPr>
+              <a:defRPr sz="1000">
+                <a:solidFill>
+                  <a:srgbClr val="D4D4D4"/>
+                </a:solidFill>
+                <a:latin typeface="Courier New"/>
+              </a:defRPr>
+            </a:pPr>
             <a:r>
-              <a:t>existing floating point infrastructure...</a:t>
+              <a:t>existing floating point infrastructure and</a:t>
+            </a:r>
+          </a:p>
+          <a:p>
+            <a:pPr>
+              <a:defRPr sz="1000">
+                <a:solidFill>
+                  <a:srgbClr val="D4D4D4"/>
+                </a:solidFill>
+                <a:latin typeface="Courier New"/>
+              </a:defRPr>
+            </a:pPr>
+            <a:r>
+              <a:t>the target structure before planning.</a:t>
+            </a:r>
+          </a:p>
+          <a:p>
+            <a:pPr>
+              <a:defRPr sz="1000">
+                <a:solidFill>
+                  <a:srgbClr val="D4D4D4"/>
+                </a:solidFill>
+                <a:latin typeface="Courier New"/>
+              </a:defRPr>
+            </a:pPr>
+          </a:p>
+          <a:p>
+            <a:pPr>
+              <a:defRPr sz="1000">
+                <a:solidFill>
+                  <a:srgbClr val="D4D4D4"/>
+                </a:solidFill>
+                <a:latin typeface="Courier New"/>
+              </a:defRPr>
+            </a:pPr>
+            <a:r>
+              <a:t>  Agent(Explore): existing FP infrastructure</a:t>
+            </a:r>
+          </a:p>
+          <a:p>
+            <a:pPr>
+              <a:defRPr sz="1000">
+                <a:solidFill>
+                  <a:srgbClr val="D4D4D4"/>
+                </a:solidFill>
+                <a:latin typeface="Courier New"/>
+              </a:defRPr>
+            </a:pPr>
+            <a:r>
+              <a:t>  Agent(Explore): target and data path</a:t>
+            </a:r>
+          </a:p>
+          <a:p>
+            <a:pPr>
+              <a:defRPr sz="1000">
+                <a:solidFill>
+                  <a:srgbClr val="D4D4D4"/>
+                </a:solidFill>
+                <a:latin typeface="Courier New"/>
+              </a:defRPr>
+            </a:pPr>
+            <a:r>
+              <a:t>  Agent(Explore): PID state and RAM usage</a:t>
+            </a:r>
+          </a:p>
+          <a:p>
+            <a:pPr>
+              <a:defRPr sz="1000">
+                <a:solidFill>
+                  <a:srgbClr val="D4D4D4"/>
+                </a:solidFill>
+                <a:latin typeface="Courier New"/>
+              </a:defRPr>
+            </a:pPr>
+          </a:p>
+          <a:p>
+            <a:pPr>
+              <a:defRPr sz="1000">
+                <a:solidFill>
+                  <a:srgbClr val="D4D4D4"/>
+                </a:solidFill>
+                <a:latin typeface="Courier New"/>
+              </a:defRPr>
+            </a:pPr>
+            <a:r>
+              <a:t>Found: FpMac (4-cyc FMA), Int2Fp (2-cyc),</a:t>
+            </a:r>
+          </a:p>
+          <a:p>
+            <a:pPr>
+              <a:defRPr sz="1000">
+                <a:solidFill>
+                  <a:srgbClr val="D4D4D4"/>
+                </a:solidFill>
+                <a:latin typeface="Courier New"/>
+              </a:defRPr>
+            </a:pPr>
+            <a:r>
+              <a:t>BiquadFilter.vhd demonstrates the pattern...</a:t>
             </a:r>
           </a:p>
         </p:txBody>
@@ -41553,8 +42116,8 @@
         </p:nvSpPr>
         <p:spPr>
           <a:xfrm>
-            <a:off x="5300000" y="1500000"/>
-            <a:ext cx="6200000" cy="1000000"/>
+            <a:off x="5100000" y="1500000"/>
+            <a:ext cx="6500000" cy="4800000"/>
           </a:xfrm>
           <a:prstGeom prst="roundRect">
             <a:avLst/>
@@ -41595,8 +42158,57 @@
               </a:defRPr>
             </a:pPr>
             <a:r>
-              <a:t>── AGENTS.md ──</a:t>
+              <a:t>── AGENTS.md (excerpts) ──</a:t>
             </a:r>
+          </a:p>
+          <a:p>
+            <a:pPr>
+              <a:defRPr sz="1000">
+                <a:solidFill>
+                  <a:srgbClr val="D4D4D4"/>
+                </a:solidFill>
+                <a:latin typeface="Courier New"/>
+              </a:defRPr>
+            </a:pPr>
+            <a:r>
+              <a:t>## Project Summary</a:t>
+            </a:r>
+          </a:p>
+          <a:p>
+            <a:pPr>
+              <a:defRPr sz="1000">
+                <a:solidFill>
+                  <a:srgbClr val="D4D4D4"/>
+                </a:solidFill>
+                <a:latin typeface="Courier New"/>
+              </a:defRPr>
+            </a:pPr>
+            <a:r>
+              <a:t>Warm TDM is a time-division multiplexing detector</a:t>
+            </a:r>
+          </a:p>
+          <a:p>
+            <a:pPr>
+              <a:defRPr sz="1000">
+                <a:solidFill>
+                  <a:srgbClr val="D4D4D4"/>
+                </a:solidFill>
+                <a:latin typeface="Courier New"/>
+              </a:defRPr>
+            </a:pPr>
+            <a:r>
+              <a:t>readout system for TES bolometric detector arrays.</a:t>
+            </a:r>
+          </a:p>
+          <a:p>
+            <a:pPr>
+              <a:defRPr sz="1000">
+                <a:solidFill>
+                  <a:srgbClr val="D4D4D4"/>
+                </a:solidFill>
+                <a:latin typeface="Courier New"/>
+              </a:defRPr>
+            </a:pPr>
           </a:p>
           <a:p>
             <a:pPr>
@@ -41620,18 +42232,8 @@
                 <a:latin typeface="Courier New"/>
               </a:defRPr>
             </a:pPr>
-          </a:p>
-          <a:p>
-            <a:pPr>
-              <a:defRPr sz="1000">
-                <a:solidFill>
-                  <a:srgbClr val="D4D4D4"/>
-                </a:solidFill>
-                <a:latin typeface="Courier New"/>
-              </a:defRPr>
-            </a:pPr>
             <a:r>
-              <a:t>AD9681 ADC → DataPath → AdcDsp (PID) → EventBuilder → Host</a:t>
+              <a:t>AD9681 ADC → DataPath → AdcDsp (PID + flux-jump)</a:t>
             </a:r>
           </a:p>
           <a:p>
@@ -41644,7 +42246,7 @@
               </a:defRPr>
             </a:pPr>
             <a:r>
-              <a:t>                             ↕</a:t>
+              <a:t>  → EventBuilder → PGP Stream → Host</a:t>
             </a:r>
           </a:p>
           <a:p>
@@ -41657,62 +42259,7 @@
               </a:defRPr>
             </a:pPr>
             <a:r>
-              <a:t>                   FastDacDriver (SQ1 feedback)</a:t>
-            </a:r>
-          </a:p>
-        </p:txBody>
-      </p:sp>
-      <p:sp>
-        <p:nvSpPr>
-          <p:cNvPr id="7" name="Rounded Rectangle 6"/>
-          <p:cNvSpPr/>
-          <p:nvPr/>
-        </p:nvSpPr>
-        <p:spPr>
-          <a:xfrm>
-            <a:off x="5300000" y="2650000"/>
-            <a:ext cx="6200000" cy="900000"/>
-          </a:xfrm>
-          <a:prstGeom prst="roundRect">
-            <a:avLst/>
-          </a:prstGeom>
-          <a:solidFill>
-            <a:srgbClr val="1E1E2E"/>
-          </a:solidFill>
-          <a:ln w="12700">
-            <a:solidFill>
-              <a:srgbClr val="444455"/>
-            </a:solidFill>
-          </a:ln>
-        </p:spPr>
-        <p:style>
-          <a:lnRef idx="1">
-            <a:schemeClr val="accent1"/>
-          </a:lnRef>
-          <a:fillRef idx="3">
-            <a:schemeClr val="accent1"/>
-          </a:fillRef>
-          <a:effectRef idx="2">
-            <a:schemeClr val="accent1"/>
-          </a:effectRef>
-          <a:fontRef idx="minor">
-            <a:schemeClr val="lt1"/>
-          </a:fontRef>
-        </p:style>
-        <p:txBody>
-          <a:bodyPr rtlCol="0" anchor="ctr" wrap="square" lIns="150000" tIns="100000" rIns="150000"/>
-          <a:lstStyle/>
-          <a:p>
-            <a:pPr algn="ctr">
-              <a:defRPr sz="1000">
-                <a:solidFill>
-                  <a:srgbClr val="D4D4D4"/>
-                </a:solidFill>
-                <a:latin typeface="Courier New"/>
-              </a:defRPr>
-            </a:pPr>
-            <a:r>
-              <a:t>| Task Area       | Start With These Files             |</a:t>
+              <a:t>       ↕ FastDacDriver (SQ1 feedback)</a:t>
             </a:r>
           </a:p>
           <a:p>
@@ -41724,8 +42271,18 @@
                 <a:latin typeface="Courier New"/>
               </a:defRPr>
             </a:pPr>
+          </a:p>
+          <a:p>
+            <a:pPr>
+              <a:defRPr sz="1000">
+                <a:solidFill>
+                  <a:srgbClr val="D4D4D4"/>
+                </a:solidFill>
+                <a:latin typeface="Courier New"/>
+              </a:defRPr>
+            </a:pPr>
             <a:r>
-              <a:t>|─────────────────|────────────────────────────────────|</a:t>
+              <a:t>## Essential Reading by Task</a:t>
             </a:r>
           </a:p>
           <a:p>
@@ -41738,7 +42295,7 @@
               </a:defRPr>
             </a:pPr>
             <a:r>
-              <a:t>| DSP / data path | DataPath.vhd, AdcDsp.vhd,          |</a:t>
+              <a:t>| Task Area       | Start With               |</a:t>
             </a:r>
           </a:p>
           <a:p>
@@ -41751,53 +42308,73 @@
               </a:defRPr>
             </a:pPr>
             <a:r>
-              <a:t>|                 | BiquadFilter.vhd, EventBuilder.vhd |</a:t>
+              <a:t>|-----------------|--------------------------|</a:t>
             </a:r>
           </a:p>
-        </p:txBody>
-      </p:sp>
-      <p:sp>
-        <p:nvSpPr>
-          <p:cNvPr id="8" name="Rounded Rectangle 7"/>
-          <p:cNvSpPr/>
-          <p:nvPr/>
-        </p:nvSpPr>
-        <p:spPr>
-          <a:xfrm>
-            <a:off x="5300000" y="3700000"/>
-            <a:ext cx="6200000" cy="750000"/>
-          </a:xfrm>
-          <a:prstGeom prst="roundRect">
-            <a:avLst/>
-          </a:prstGeom>
-          <a:solidFill>
-            <a:srgbClr val="1E1E2E"/>
-          </a:solidFill>
-          <a:ln w="12700">
-            <a:solidFill>
-              <a:srgbClr val="444455"/>
-            </a:solidFill>
-          </a:ln>
-        </p:spPr>
-        <p:style>
-          <a:lnRef idx="1">
-            <a:schemeClr val="accent1"/>
-          </a:lnRef>
-          <a:fillRef idx="3">
-            <a:schemeClr val="accent1"/>
-          </a:fillRef>
-          <a:effectRef idx="2">
-            <a:schemeClr val="accent1"/>
-          </a:effectRef>
-          <a:fontRef idx="minor">
-            <a:schemeClr val="lt1"/>
-          </a:fontRef>
-        </p:style>
-        <p:txBody>
-          <a:bodyPr rtlCol="0" anchor="ctr" wrap="square" lIns="150000" tIns="100000" rIns="150000"/>
-          <a:lstStyle/>
           <a:p>
-            <a:pPr algn="ctr">
+            <a:pPr>
+              <a:defRPr sz="1000">
+                <a:solidFill>
+                  <a:srgbClr val="D4D4D4"/>
+                </a:solidFill>
+                <a:latin typeface="Courier New"/>
+              </a:defRPr>
+            </a:pPr>
+            <a:r>
+              <a:t>| DSP / data path | DataPath.vhd, AdcDsp.vhd |</a:t>
+            </a:r>
+          </a:p>
+          <a:p>
+            <a:pPr>
+              <a:defRPr sz="1000">
+                <a:solidFill>
+                  <a:srgbClr val="D4D4D4"/>
+                </a:solidFill>
+                <a:latin typeface="Courier New"/>
+              </a:defRPr>
+            </a:pPr>
+            <a:r>
+              <a:t>|                 | BiquadFilter.vhd          |</a:t>
+            </a:r>
+          </a:p>
+          <a:p>
+            <a:pPr>
+              <a:defRPr sz="1000">
+                <a:solidFill>
+                  <a:srgbClr val="D4D4D4"/>
+                </a:solidFill>
+                <a:latin typeface="Courier New"/>
+              </a:defRPr>
+            </a:pPr>
+            <a:r>
+              <a:t>| Timing protocol | TimingPkg.vhd, TimingTx   |</a:t>
+            </a:r>
+          </a:p>
+          <a:p>
+            <a:pPr>
+              <a:defRPr sz="1000">
+                <a:solidFill>
+                  <a:srgbClr val="D4D4D4"/>
+                </a:solidFill>
+                <a:latin typeface="Courier New"/>
+              </a:defRPr>
+            </a:pPr>
+            <a:r>
+              <a:t>| Communication   | PgpEthCore, RingRouter    |</a:t>
+            </a:r>
+          </a:p>
+          <a:p>
+            <a:pPr>
+              <a:defRPr sz="1000">
+                <a:solidFill>
+                  <a:srgbClr val="D4D4D4"/>
+                </a:solidFill>
+                <a:latin typeface="Courier New"/>
+              </a:defRPr>
+            </a:pPr>
+          </a:p>
+          <a:p>
+            <a:pPr>
               <a:defRPr sz="1000">
                 <a:solidFill>
                   <a:srgbClr val="D4D4D4"/>
@@ -41819,7 +42396,7 @@
               </a:defRPr>
             </a:pPr>
             <a:r>
-              <a:t>- Generics suffixed _G (e.g., TPD_G, SIMULATION_G)</a:t>
+              <a:t>- Library: All RTL loaded as -lib warm_tdm</a:t>
             </a:r>
           </a:p>
           <a:p>
@@ -41832,7 +42409,7 @@
               </a:defRPr>
             </a:pPr>
             <a:r>
-              <a:t>- Constants suffixed _C (e.g., AXIL_CLK_FREQ_C)</a:t>
+              <a:t>- VHDL standard: 2008</a:t>
             </a:r>
           </a:p>
           <a:p>
@@ -41845,62 +42422,7 @@
               </a:defRPr>
             </a:pPr>
             <a:r>
-              <a:t>- Architecture always named `rtl`</a:t>
-            </a:r>
-          </a:p>
-        </p:txBody>
-      </p:sp>
-      <p:sp>
-        <p:nvSpPr>
-          <p:cNvPr id="9" name="Rounded Rectangle 8"/>
-          <p:cNvSpPr/>
-          <p:nvPr/>
-        </p:nvSpPr>
-        <p:spPr>
-          <a:xfrm>
-            <a:off x="5300000" y="4600000"/>
-            <a:ext cx="6200000" cy="600000"/>
-          </a:xfrm>
-          <a:prstGeom prst="roundRect">
-            <a:avLst/>
-          </a:prstGeom>
-          <a:solidFill>
-            <a:srgbClr val="1E1E2E"/>
-          </a:solidFill>
-          <a:ln w="12700">
-            <a:solidFill>
-              <a:srgbClr val="444455"/>
-            </a:solidFill>
-          </a:ln>
-        </p:spPr>
-        <p:style>
-          <a:lnRef idx="1">
-            <a:schemeClr val="accent1"/>
-          </a:lnRef>
-          <a:fillRef idx="3">
-            <a:schemeClr val="accent1"/>
-          </a:fillRef>
-          <a:effectRef idx="2">
-            <a:schemeClr val="accent1"/>
-          </a:effectRef>
-          <a:fontRef idx="minor">
-            <a:schemeClr val="lt1"/>
-          </a:fontRef>
-        </p:style>
-        <p:txBody>
-          <a:bodyPr rtlCol="0" anchor="ctr" wrap="square" lIns="150000" tIns="100000" rIns="150000"/>
-          <a:lstStyle/>
-          <a:p>
-            <a:pPr algn="ctr">
-              <a:defRPr sz="1000">
-                <a:solidFill>
-                  <a:srgbClr val="D4D4D4"/>
-                </a:solidFill>
-                <a:latin typeface="Courier New"/>
-              </a:defRPr>
-            </a:pPr>
-            <a:r>
-              <a:t>For substantial feature work, keep planning, progress,</a:t>
+              <a:t>- Generics suffixed _G (TPD_G, SIMULATION_G)</a:t>
             </a:r>
           </a:p>
           <a:p>
@@ -41913,7 +42435,69 @@
               </a:defRPr>
             </a:pPr>
             <a:r>
-              <a:t>and handoff Markdown under docs/plans/&lt;task-name&gt;/.</a:t>
+              <a:t>- Constants suffixed _C (AXIL_CLK_FREQ_C)</a:t>
+            </a:r>
+          </a:p>
+          <a:p>
+            <a:pPr>
+              <a:defRPr sz="1000">
+                <a:solidFill>
+                  <a:srgbClr val="D4D4D4"/>
+                </a:solidFill>
+                <a:latin typeface="Courier New"/>
+              </a:defRPr>
+            </a:pPr>
+            <a:r>
+              <a:t>- Architecture always named `rtl`</a:t>
+            </a:r>
+          </a:p>
+          <a:p>
+            <a:pPr>
+              <a:defRPr sz="1000">
+                <a:solidFill>
+                  <a:srgbClr val="D4D4D4"/>
+                </a:solidFill>
+                <a:latin typeface="Courier New"/>
+              </a:defRPr>
+            </a:pPr>
+          </a:p>
+          <a:p>
+            <a:pPr>
+              <a:defRPr sz="1000">
+                <a:solidFill>
+                  <a:srgbClr val="D4D4D4"/>
+                </a:solidFill>
+                <a:latin typeface="Courier New"/>
+              </a:defRPr>
+            </a:pPr>
+            <a:r>
+              <a:t>For substantial feature work, keep planning,</a:t>
+            </a:r>
+          </a:p>
+          <a:p>
+            <a:pPr>
+              <a:defRPr sz="1000">
+                <a:solidFill>
+                  <a:srgbClr val="D4D4D4"/>
+                </a:solidFill>
+                <a:latin typeface="Courier New"/>
+              </a:defRPr>
+            </a:pPr>
+            <a:r>
+              <a:t>progress, and handoff Markdown under</a:t>
+            </a:r>
+          </a:p>
+          <a:p>
+            <a:pPr>
+              <a:defRPr sz="1000">
+                <a:solidFill>
+                  <a:srgbClr val="D4D4D4"/>
+                </a:solidFill>
+                <a:latin typeface="Courier New"/>
+              </a:defRPr>
+            </a:pPr>
+            <a:r>
+              <a:t>docs/plans/&lt;task-name&gt;/.</a:t>
             </a:r>
           </a:p>
         </p:txBody>
@@ -43151,7 +43735,7 @@
         <p:spPr>
           <a:xfrm>
             <a:off x="548640" y="1600000"/>
-            <a:ext cx="5200000" cy="5000000"/>
+            <a:ext cx="5400000" cy="5000000"/>
           </a:xfrm>
           <a:prstGeom prst="rect">
             <a:avLst/>
@@ -43165,7 +43749,7 @@
           <a:lstStyle/>
           <a:p>
             <a:pPr>
-              <a:defRPr sz="1400" b="1">
+              <a:defRPr sz="1300" b="1">
                 <a:solidFill>
                   <a:srgbClr val="2E7D32"/>
                 </a:solidFill>
@@ -43177,38 +43761,67 @@
           </a:p>
           <a:p>
             <a:pPr>
-              <a:defRPr sz="1200" b="0">
-                <a:solidFill>
-                  <a:srgbClr val="5C5C5C"/>
-                </a:solidFill>
+              <a:defRPr sz="1100" b="1">
+                <a:solidFill>
+                  <a:srgbClr val="2B2B2B"/>
+                </a:solidFill>
+                <a:latin typeface="Courier New"/>
               </a:defRPr>
             </a:pPr>
             <a:r>
-              <a:t>  AdcDspFp.vhd      — 600-line FP PID module</a:t>
+              <a:t>firmware/common/warm_tdm/</a:t>
             </a:r>
           </a:p>
           <a:p>
             <a:pPr>
-              <a:defRPr sz="1200" b="0">
+              <a:defRPr sz="1100" b="0">
                 <a:solidFill>
                   <a:srgbClr val="5C5C5C"/>
                 </a:solidFill>
+                <a:latin typeface="Courier New"/>
               </a:defRPr>
             </a:pPr>
             <a:r>
-              <a:t>  Fp2Int.xci          — Xilinx IP core (float→int)</a:t>
+              <a:t>  rtl/AdcDspFp.vhd</a:t>
             </a:r>
           </a:p>
           <a:p>
             <a:pPr>
-              <a:defRPr sz="1200" b="0">
+              <a:defRPr sz="1100" b="0">
                 <a:solidFill>
                   <a:srgbClr val="5C5C5C"/>
                 </a:solidFill>
+                <a:latin typeface="Courier New"/>
               </a:defRPr>
             </a:pPr>
             <a:r>
-              <a:t>  _AdcDspFp.py       — Python register driver</a:t>
+              <a:t>  ip/Fp2Int/Fp2Int.xci</a:t>
+            </a:r>
+          </a:p>
+          <a:p>
+            <a:pPr>
+              <a:defRPr sz="1100" b="1">
+                <a:solidFill>
+                  <a:srgbClr val="2B2B2B"/>
+                </a:solidFill>
+                <a:latin typeface="Courier New"/>
+              </a:defRPr>
+            </a:pPr>
+            <a:r>
+              <a:t>firmware/python/warm_tdm/</a:t>
+            </a:r>
+          </a:p>
+          <a:p>
+            <a:pPr>
+              <a:defRPr sz="1100" b="0">
+                <a:solidFill>
+                  <a:srgbClr val="5C5C5C"/>
+                </a:solidFill>
+                <a:latin typeface="Courier New"/>
+              </a:defRPr>
+            </a:pPr>
+            <a:r>
+              <a:t>  _AdcDspFp.py</a:t>
             </a:r>
           </a:p>
           <a:p>
@@ -43222,7 +43835,7 @@
           </a:p>
           <a:p>
             <a:pPr>
-              <a:defRPr sz="1400" b="1">
+              <a:defRPr sz="1300" b="1">
                 <a:solidFill>
                   <a:srgbClr val="1B3A5C"/>
                 </a:solidFill>
@@ -43234,107 +43847,184 @@
           </a:p>
           <a:p>
             <a:pPr>
-              <a:defRPr sz="1200" b="0">
-                <a:solidFill>
-                  <a:srgbClr val="5C5C5C"/>
-                </a:solidFill>
+              <a:defRPr sz="1100" b="1">
+                <a:solidFill>
+                  <a:srgbClr val="2B2B2B"/>
+                </a:solidFill>
+                <a:latin typeface="Courier New"/>
               </a:defRPr>
             </a:pPr>
             <a:r>
-              <a:t>  DataPath.vhd       — generate blocks</a:t>
+              <a:t>firmware/common/warm_tdm/</a:t>
             </a:r>
           </a:p>
           <a:p>
             <a:pPr>
-              <a:defRPr sz="1200" b="0">
+              <a:defRPr sz="1100" b="0">
                 <a:solidFill>
                   <a:srgbClr val="5C5C5C"/>
                 </a:solidFill>
+                <a:latin typeface="Courier New"/>
               </a:defRPr>
             </a:pPr>
             <a:r>
-              <a:t>  BiquadFilter.vhd   — float bypass</a:t>
+              <a:t>  rtl/DataPath.vhd</a:t>
             </a:r>
           </a:p>
           <a:p>
             <a:pPr>
-              <a:defRPr sz="1200" b="0">
+              <a:defRPr sz="1100" b="0">
                 <a:solidFill>
                   <a:srgbClr val="5C5C5C"/>
                 </a:solidFill>
+                <a:latin typeface="Courier New"/>
               </a:defRPr>
             </a:pPr>
             <a:r>
-              <a:t>  WarmTdmPkg.vhd    — stream config</a:t>
+              <a:t>  rtl/BiquadFilter.vhd</a:t>
             </a:r>
           </a:p>
           <a:p>
             <a:pPr>
-              <a:defRPr sz="1200" b="0">
+              <a:defRPr sz="1100" b="0">
                 <a:solidFill>
                   <a:srgbClr val="5C5C5C"/>
                 </a:solidFill>
+                <a:latin typeface="Courier New"/>
               </a:defRPr>
             </a:pPr>
             <a:r>
-              <a:t>  ColumnFpgaBoard    — top generic</a:t>
+              <a:t>  rtl/WarmTdmPkg.vhd</a:t>
             </a:r>
           </a:p>
           <a:p>
             <a:pPr>
-              <a:defRPr sz="1200" b="0">
+              <a:defRPr sz="1100" b="0">
                 <a:solidFill>
                   <a:srgbClr val="5C5C5C"/>
                 </a:solidFill>
+                <a:latin typeface="Courier New"/>
               </a:defRPr>
             </a:pPr>
             <a:r>
-              <a:t>  ruckus.tcl           — IP loading</a:t>
+              <a:t>  ruckus.tcl</a:t>
             </a:r>
           </a:p>
           <a:p>
             <a:pPr>
-              <a:defRPr sz="1200" b="0">
-                <a:solidFill>
-                  <a:srgbClr val="5C5C5C"/>
-                </a:solidFill>
+              <a:defRPr sz="1100" b="1">
+                <a:solidFill>
+                  <a:srgbClr val="2B2B2B"/>
+                </a:solidFill>
+                <a:latin typeface="Courier New"/>
               </a:defRPr>
             </a:pPr>
             <a:r>
-              <a:t>  + 7 Python files    — CLI + SW stack</a:t>
+              <a:t>firmware/targets/ColumnFpgaBoard/</a:t>
             </a:r>
           </a:p>
           <a:p>
             <a:pPr>
-              <a:defRPr sz="600" b="0">
+              <a:defRPr sz="1100" b="0">
                 <a:solidFill>
                   <a:srgbClr val="5C5C5C"/>
                 </a:solidFill>
-              </a:defRPr>
-            </a:pPr>
-          </a:p>
-          <a:p>
-            <a:pPr>
-              <a:defRPr sz="1400" b="1">
-                <a:solidFill>
-                  <a:srgbClr val="2B2B2B"/>
-                </a:solidFill>
+                <a:latin typeface="Courier New"/>
               </a:defRPr>
             </a:pPr>
             <a:r>
-              <a:t>~800 lines of production code</a:t>
+              <a:t>  rtl/ColumnFpgaBoard.vhd</a:t>
             </a:r>
           </a:p>
           <a:p>
             <a:pPr>
-              <a:defRPr sz="1400" b="1">
+              <a:defRPr sz="1100" b="1">
                 <a:solidFill>
                   <a:srgbClr val="2B2B2B"/>
                 </a:solidFill>
+                <a:latin typeface="Courier New"/>
               </a:defRPr>
             </a:pPr>
             <a:r>
-              <a:t>all following existing conventions.</a:t>
+              <a:t>firmware/targets/...Coordinator10G/</a:t>
+            </a:r>
+          </a:p>
+          <a:p>
+            <a:pPr>
+              <a:defRPr sz="1100" b="0">
+                <a:solidFill>
+                  <a:srgbClr val="5C5C5C"/>
+                </a:solidFill>
+                <a:latin typeface="Courier New"/>
+              </a:defRPr>
+            </a:pPr>
+            <a:r>
+              <a:t>  ruckus.tcl</a:t>
+            </a:r>
+          </a:p>
+          <a:p>
+            <a:pPr>
+              <a:defRPr sz="1100" b="1">
+                <a:solidFill>
+                  <a:srgbClr val="2B2B2B"/>
+                </a:solidFill>
+                <a:latin typeface="Courier New"/>
+              </a:defRPr>
+            </a:pPr>
+            <a:r>
+              <a:t>firmware/python/warm_tdm/</a:t>
+            </a:r>
+          </a:p>
+          <a:p>
+            <a:pPr>
+              <a:defRPr sz="1100" b="0">
+                <a:solidFill>
+                  <a:srgbClr val="5C5C5C"/>
+                </a:solidFill>
+                <a:latin typeface="Courier New"/>
+              </a:defRPr>
+            </a:pPr>
+            <a:r>
+              <a:t>  _DataPath.py, _ColumnFpgaBoard.py</a:t>
+            </a:r>
+          </a:p>
+          <a:p>
+            <a:pPr>
+              <a:defRPr sz="1100" b="0">
+                <a:solidFill>
+                  <a:srgbClr val="5C5C5C"/>
+                </a:solidFill>
+                <a:latin typeface="Courier New"/>
+              </a:defRPr>
+            </a:pPr>
+            <a:r>
+              <a:t>  _HardwareGroup.py, __init__.py</a:t>
+            </a:r>
+          </a:p>
+          <a:p>
+            <a:pPr>
+              <a:defRPr sz="1100" b="1">
+                <a:solidFill>
+                  <a:srgbClr val="2B2B2B"/>
+                </a:solidFill>
+                <a:latin typeface="Courier New"/>
+              </a:defRPr>
+            </a:pPr>
+            <a:r>
+              <a:t>software/python/warm_tdm_api/</a:t>
+            </a:r>
+          </a:p>
+          <a:p>
+            <a:pPr>
+              <a:defRPr sz="1100" b="0">
+                <a:solidFill>
+                  <a:srgbClr val="5C5C5C"/>
+                </a:solidFill>
+                <a:latin typeface="Courier New"/>
+              </a:defRPr>
+            </a:pPr>
+            <a:r>
+              <a:t>  _ArgParser.py, _GroupRoot.py, _Group.py</a:t>
             </a:r>
           </a:p>
         </p:txBody>
@@ -44017,7 +44707,7 @@
         <p:spPr>
           <a:xfrm>
             <a:off x="6300000" y="1200000"/>
-            <a:ext cx="5100000" cy="3800000"/>
+            <a:ext cx="5100000" cy="4000000"/>
           </a:xfrm>
           <a:prstGeom prst="roundRect">
             <a:avLst/>
@@ -44046,54 +44736,377 @@
           </a:fontRef>
         </p:style>
         <p:txBody>
-          <a:bodyPr rtlCol="0" anchor="ctr" wrap="square" lIns="150000" tIns="100000"/>
+          <a:bodyPr rtlCol="0" anchor="ctr" wrap="square" lIns="150000" tIns="100000" rIns="150000"/>
           <a:lstStyle/>
           <a:p>
             <a:pPr algn="ctr">
-              <a:defRPr sz="1000">
-                <a:solidFill>
-                  <a:srgbClr val="4EC9B0"/>
+              <a:defRPr sz="900">
+                <a:solidFill>
+                  <a:srgbClr val="888899"/>
                 </a:solidFill>
                 <a:latin typeface="Courier New"/>
               </a:defRPr>
             </a:pPr>
             <a:r>
-              <a:t>[Screenshot: Review catch in terminal]</a:t>
+              <a:t>── claude ──</a:t>
             </a:r>
-            <a:br/>
-            <a:br/>
+          </a:p>
+          <a:p>
+            <a:pPr>
+              <a:defRPr sz="1000">
+                <a:solidFill>
+                  <a:srgbClr val="D4D4D4"/>
+                </a:solidFill>
+                <a:latin typeface="Courier New"/>
+              </a:defRPr>
+            </a:pPr>
             <a:r>
-              <a:t>&gt; _AdcDsp.py has P_CoefRaw, I_CoefRaw</a:t>
+              <a:t>╭─────────────────────────────────────╮</a:t>
             </a:r>
-            <a:br/>
+          </a:p>
+          <a:p>
+            <a:pPr>
+              <a:defRPr sz="1000">
+                <a:solidFill>
+                  <a:srgbClr val="D4D4D4"/>
+                </a:solidFill>
+                <a:latin typeface="Courier New"/>
+              </a:defRPr>
+            </a:pPr>
             <a:r>
-              <a:t>&gt; and D_CoefRaw. The new FP version</a:t>
+              <a:t>│ &gt; _AdcDsp.py has P_CoefRaw,         │</a:t>
             </a:r>
-            <a:br/>
+          </a:p>
+          <a:p>
+            <a:pPr>
+              <a:defRPr sz="1000">
+                <a:solidFill>
+                  <a:srgbClr val="D4D4D4"/>
+                </a:solidFill>
+                <a:latin typeface="Courier New"/>
+              </a:defRPr>
+            </a:pPr>
             <a:r>
-              <a:t>&gt; only has I_CoefRaw. Why?</a:t>
+              <a:t>│   I_CoefRaw and D_CoefRaw. The new  │</a:t>
             </a:r>
-            <a:br/>
-            <a:br/>
+          </a:p>
+          <a:p>
+            <a:pPr>
+              <a:defRPr sz="1000">
+                <a:solidFill>
+                  <a:srgbClr val="D4D4D4"/>
+                </a:solidFill>
+                <a:latin typeface="Courier New"/>
+              </a:defRPr>
+            </a:pPr>
+            <a:r>
+              <a:t>│   FP version only has I_CoefRaw.    │</a:t>
+            </a:r>
+          </a:p>
+          <a:p>
+            <a:pPr>
+              <a:defRPr sz="1000">
+                <a:solidFill>
+                  <a:srgbClr val="D4D4D4"/>
+                </a:solidFill>
+                <a:latin typeface="Courier New"/>
+              </a:defRPr>
+            </a:pPr>
+            <a:r>
+              <a:t>│   Why?                              │</a:t>
+            </a:r>
+          </a:p>
+          <a:p>
+            <a:pPr>
+              <a:defRPr sz="1000">
+                <a:solidFill>
+                  <a:srgbClr val="D4D4D4"/>
+                </a:solidFill>
+                <a:latin typeface="Courier New"/>
+              </a:defRPr>
+            </a:pPr>
+            <a:r>
+              <a:t>╰─────────────────────────────────────╯</a:t>
+            </a:r>
+          </a:p>
+          <a:p>
+            <a:pPr>
+              <a:defRPr sz="1000">
+                <a:solidFill>
+                  <a:srgbClr val="D4D4D4"/>
+                </a:solidFill>
+                <a:latin typeface="Courier New"/>
+              </a:defRPr>
+            </a:pPr>
+          </a:p>
+          <a:p>
+            <a:pPr>
+              <a:defRPr sz="1000">
+                <a:solidFill>
+                  <a:srgbClr val="D4D4D4"/>
+                </a:solidFill>
+                <a:latin typeface="Courier New"/>
+              </a:defRPr>
+            </a:pPr>
+            <a:r>
+              <a:t>No good reason — it was an oversight.</a:t>
+            </a:r>
+          </a:p>
+          <a:p>
+            <a:pPr>
+              <a:defRPr sz="1000">
+                <a:solidFill>
+                  <a:srgbClr val="D4D4D4"/>
+                </a:solidFill>
+                <a:latin typeface="Courier New"/>
+              </a:defRPr>
+            </a:pPr>
             <a:r>
               <a:t>In the original, all three use the</a:t>
             </a:r>
-            <a:br/>
+          </a:p>
+          <a:p>
+            <a:pPr>
+              <a:defRPr sz="1000">
+                <a:solidFill>
+                  <a:srgbClr val="D4D4D4"/>
+                </a:solidFill>
+                <a:latin typeface="Courier New"/>
+              </a:defRPr>
+            </a:pPr>
             <a:r>
-              <a:t>Raw/Link pattern... I simplified P</a:t>
+              <a:t>Raw/Link pattern...</a:t>
             </a:r>
-            <a:br/>
+          </a:p>
+          <a:p>
+            <a:pPr>
+              <a:defRPr sz="1000">
+                <a:solidFill>
+                  <a:srgbClr val="D4D4D4"/>
+                </a:solidFill>
+                <a:latin typeface="Courier New"/>
+              </a:defRPr>
+            </a:pPr>
+          </a:p>
+          <a:p>
+            <a:pPr>
+              <a:defRPr sz="1000">
+                <a:solidFill>
+                  <a:srgbClr val="D4D4D4"/>
+                </a:solidFill>
+                <a:latin typeface="Courier New"/>
+              </a:defRPr>
+            </a:pPr>
             <a:r>
-              <a:t>and D. Should I add Raw/Link for all</a:t>
+              <a:t>Should I add Raw/Link for all three</a:t>
             </a:r>
-            <a:br/>
+          </a:p>
+          <a:p>
+            <a:pPr>
+              <a:defRPr sz="1000">
+                <a:solidFill>
+                  <a:srgbClr val="D4D4D4"/>
+                </a:solidFill>
+                <a:latin typeface="Courier New"/>
+              </a:defRPr>
+            </a:pPr>
             <a:r>
-              <a:t>three for consistency?</a:t>
+              <a:t>for consistency?</a:t>
             </a:r>
-            <a:br/>
-            <a:br/>
+          </a:p>
+          <a:p>
+            <a:pPr>
+              <a:defRPr sz="1000">
+                <a:solidFill>
+                  <a:srgbClr val="D4D4D4"/>
+                </a:solidFill>
+                <a:latin typeface="Courier New"/>
+              </a:defRPr>
+            </a:pPr>
+          </a:p>
+          <a:p>
+            <a:pPr>
+              <a:defRPr sz="1000">
+                <a:solidFill>
+                  <a:srgbClr val="D4D4D4"/>
+                </a:solidFill>
+                <a:latin typeface="Courier New"/>
+              </a:defRPr>
+            </a:pPr>
             <a:r>
-              <a:t>→ Add Raw/Link for all three</a:t>
+              <a:t>  ● Add Raw/Link for all three</a:t>
+            </a:r>
+          </a:p>
+          <a:p>
+            <a:pPr>
+              <a:defRPr sz="1000">
+                <a:solidFill>
+                  <a:srgbClr val="D4D4D4"/>
+                </a:solidFill>
+                <a:latin typeface="Courier New"/>
+              </a:defRPr>
+            </a:pPr>
+            <a:r>
+              <a:t>  ○ Keep as-is (simplified)</a:t>
+            </a:r>
+          </a:p>
+          <a:p>
+            <a:pPr>
+              <a:defRPr sz="1000">
+                <a:solidFill>
+                  <a:srgbClr val="D4D4D4"/>
+                </a:solidFill>
+                <a:latin typeface="Courier New"/>
+              </a:defRPr>
+            </a:pPr>
+          </a:p>
+          <a:p>
+            <a:pPr>
+              <a:defRPr sz="1000">
+                <a:solidFill>
+                  <a:srgbClr val="D4D4D4"/>
+                </a:solidFill>
+                <a:latin typeface="Courier New"/>
+              </a:defRPr>
+            </a:pPr>
+            <a:r>
+              <a:t>───────────────────────────────────────</a:t>
+            </a:r>
+          </a:p>
+          <a:p>
+            <a:pPr>
+              <a:defRPr sz="1000">
+                <a:solidFill>
+                  <a:srgbClr val="D4D4D4"/>
+                </a:solidFill>
+                <a:latin typeface="Courier New"/>
+              </a:defRPr>
+            </a:pPr>
+            <a:r>
+              <a:t>╭─────────────────────────────────────╮</a:t>
+            </a:r>
+          </a:p>
+          <a:p>
+            <a:pPr>
+              <a:defRPr sz="1000">
+                <a:solidFill>
+                  <a:srgbClr val="D4D4D4"/>
+                </a:solidFill>
+                <a:latin typeface="Courier New"/>
+              </a:defRPr>
+            </a:pPr>
+            <a:r>
+              <a:t>│ &gt; There should be just one non-     │</a:t>
+            </a:r>
+          </a:p>
+          <a:p>
+            <a:pPr>
+              <a:defRPr sz="1000">
+                <a:solidFill>
+                  <a:srgbClr val="D4D4D4"/>
+                </a:solidFill>
+                <a:latin typeface="Courier New"/>
+              </a:defRPr>
+            </a:pPr>
+            <a:r>
+              <a:t>│   hidden FluxQuantum LinkVariable.  │</a:t>
+            </a:r>
+          </a:p>
+          <a:p>
+            <a:pPr>
+              <a:defRPr sz="1000">
+                <a:solidFill>
+                  <a:srgbClr val="D4D4D4"/>
+                </a:solidFill>
+                <a:latin typeface="Courier New"/>
+              </a:defRPr>
+            </a:pPr>
+            <a:r>
+              <a:t>│   It should set all raw registers.  │</a:t>
+            </a:r>
+          </a:p>
+          <a:p>
+            <a:pPr>
+              <a:defRPr sz="1000">
+                <a:solidFill>
+                  <a:srgbClr val="D4D4D4"/>
+                </a:solidFill>
+                <a:latin typeface="Courier New"/>
+              </a:defRPr>
+            </a:pPr>
+            <a:r>
+              <a:t>╰─────────────────────────────────────╯</a:t>
+            </a:r>
+          </a:p>
+        </p:txBody>
+      </p:sp>
+      <p:sp>
+        <p:nvSpPr>
+          <p:cNvPr id="8" name="TextBox 7"/>
+          <p:cNvSpPr txBox="1"/>
+          <p:nvPr/>
+        </p:nvSpPr>
+        <p:spPr>
+          <a:xfrm>
+            <a:off x="6300000" y="5400000"/>
+            <a:ext cx="5100000" cy="5000000"/>
+          </a:xfrm>
+          <a:prstGeom prst="rect">
+            <a:avLst/>
+          </a:prstGeom>
+          <a:noFill/>
+        </p:spPr>
+        <p:txBody>
+          <a:bodyPr wrap="square">
+            <a:spAutoFit/>
+          </a:bodyPr>
+          <a:lstStyle/>
+          <a:p>
+            <a:pPr>
+              <a:defRPr sz="1100" b="0">
+                <a:solidFill>
+                  <a:srgbClr val="5C5C5C"/>
+                </a:solidFill>
+              </a:defRPr>
+            </a:pPr>
+            <a:r>
+              <a:t>Note: The software side was underspecified</a:t>
+            </a:r>
+          </a:p>
+          <a:p>
+            <a:pPr>
+              <a:defRPr sz="1100" b="0">
+                <a:solidFill>
+                  <a:srgbClr val="5C5C5C"/>
+                </a:solidFill>
+              </a:defRPr>
+            </a:pPr>
+            <a:r>
+              <a:t>in the original prompt and plan. Additional</a:t>
+            </a:r>
+          </a:p>
+          <a:p>
+            <a:pPr>
+              <a:defRPr sz="1100" b="0">
+                <a:solidFill>
+                  <a:srgbClr val="5C5C5C"/>
+                </a:solidFill>
+              </a:defRPr>
+            </a:pPr>
+            <a:r>
+              <a:t>prompting was needed to generate the Python</a:t>
+            </a:r>
+          </a:p>
+          <a:p>
+            <a:pPr>
+              <a:defRPr sz="1100" b="0">
+                <a:solidFill>
+                  <a:srgbClr val="5C5C5C"/>
+                </a:solidFill>
+              </a:defRPr>
+            </a:pPr>
+            <a:r>
+              <a:t>drivers and CLI integration correctly.</a:t>
             </a:r>
           </a:p>
         </p:txBody>

</xml_diff>

<commit_message>
Update demo presentation (v3).
- Reduce corner rounding on code blocks
- Expand all right-side boxes to use more vertical space
- Slide 3: Note VSCode plugin, explain Plan Mode
- Slide 6: Terminal-style Q&A with more questions shown
- Slide 8: Taller terminal box, more review catches,
  underspecified-software note moved to left column
- All boxes filled with more content

Co-Authored-By: Claude Opus 4.6 (1M context) <noreply@anthropic.com>
</commit_message>
<xml_diff>
--- a/docs/plans/fp-dsp-pid/ECC_AI_Demo_Use_Case_2.pptx
+++ b/docs/plans/fp-dsp-pid/ECC_AI_Demo_Use_Case_2.pptx
@@ -40857,7 +40857,9 @@
             <a:ext cx="4800000" cy="4500000"/>
           </a:xfrm>
           <a:prstGeom prst="roundRect">
-            <a:avLst/>
+            <a:avLst>
+              <a:gd name="adj" fmla="val 2000"/>
+            </a:avLst>
           </a:prstGeom>
           <a:solidFill>
             <a:srgbClr val="1E1E2E"/>
@@ -41372,7 +41374,7 @@
         <p:spPr>
           <a:xfrm>
             <a:off x="548640" y="1600000"/>
-            <a:ext cx="5200000" cy="5000000"/>
+            <a:ext cx="5000000" cy="5000000"/>
           </a:xfrm>
           <a:prstGeom prst="rect">
             <a:avLst/>
@@ -41386,83 +41388,14 @@
           <a:lstStyle/>
           <a:p>
             <a:pPr>
-              <a:defRPr sz="1400" b="0">
+              <a:defRPr sz="1300" b="0">
                 <a:solidFill>
                   <a:srgbClr val="5C5C5C"/>
                 </a:solidFill>
               </a:defRPr>
             </a:pPr>
             <a:r>
-              <a:t>1. Explore — Agent reads codebase, understands architecture</a:t>
-            </a:r>
-          </a:p>
-          <a:p>
-            <a:pPr>
-              <a:defRPr sz="1400" b="0">
-                <a:solidFill>
-                  <a:srgbClr val="5C5C5C"/>
-                </a:solidFill>
-              </a:defRPr>
-            </a:pPr>
-            <a:r>
-              <a:t>2. Plan — Proposes approach, asks clarifying questions</a:t>
-            </a:r>
-          </a:p>
-          <a:p>
-            <a:pPr>
-              <a:defRPr sz="1400" b="0">
-                <a:solidFill>
-                  <a:srgbClr val="5C5C5C"/>
-                </a:solidFill>
-              </a:defRPr>
-            </a:pPr>
-            <a:r>
-              <a:t>3. Implement — Writes code across multiple files</a:t>
-            </a:r>
-          </a:p>
-          <a:p>
-            <a:pPr>
-              <a:defRPr sz="1400" b="0">
-                <a:solidFill>
-                  <a:srgbClr val="5C5C5C"/>
-                </a:solidFill>
-              </a:defRPr>
-            </a:pPr>
-            <a:r>
-              <a:t>4. Iterate — Responds to feedback, fixes issues</a:t>
-            </a:r>
-          </a:p>
-          <a:p>
-            <a:pPr>
-              <a:defRPr sz="1400" b="0">
-                <a:solidFill>
-                  <a:srgbClr val="5C5C5C"/>
-                </a:solidFill>
-              </a:defRPr>
-            </a:pPr>
-            <a:r>
-              <a:t>5. Document — Creates plan docs and progress tracking</a:t>
-            </a:r>
-          </a:p>
-          <a:p>
-            <a:pPr>
-              <a:defRPr sz="800" b="0">
-                <a:solidFill>
-                  <a:srgbClr val="5C5C5C"/>
-                </a:solidFill>
-              </a:defRPr>
-            </a:pPr>
-          </a:p>
-          <a:p>
-            <a:pPr>
-              <a:defRPr sz="1300" b="0">
-                <a:solidFill>
-                  <a:srgbClr val="5C5C5C"/>
-                </a:solidFill>
-              </a:defRPr>
-            </a:pPr>
-            <a:r>
-              <a:t>~30 minutes of interaction for a feature that would</a:t>
+              <a:t>Used via VSCode extension (also</a:t>
             </a:r>
           </a:p>
           <a:p>
@@ -41474,7 +41407,154 @@
               </a:defRPr>
             </a:pPr>
             <a:r>
-              <a:t>take a day or more by hand.</a:t>
+              <a:t>available as CLI and web app)</a:t>
+            </a:r>
+          </a:p>
+          <a:p>
+            <a:pPr>
+              <a:defRPr sz="600" b="0">
+                <a:solidFill>
+                  <a:srgbClr val="5C5C5C"/>
+                </a:solidFill>
+              </a:defRPr>
+            </a:pPr>
+          </a:p>
+          <a:p>
+            <a:pPr>
+              <a:defRPr sz="1400" b="1">
+                <a:solidFill>
+                  <a:srgbClr val="2B2B2B"/>
+                </a:solidFill>
+              </a:defRPr>
+            </a:pPr>
+            <a:r>
+              <a:t>Started in Plan Mode:</a:t>
+            </a:r>
+          </a:p>
+          <a:p>
+            <a:pPr>
+              <a:defRPr sz="1300" b="0">
+                <a:solidFill>
+                  <a:srgbClr val="5C5C5C"/>
+                </a:solidFill>
+              </a:defRPr>
+            </a:pPr>
+            <a:r>
+              <a:t>• Agent explores code (read-only)</a:t>
+            </a:r>
+          </a:p>
+          <a:p>
+            <a:pPr>
+              <a:defRPr sz="1300" b="0">
+                <a:solidFill>
+                  <a:srgbClr val="5C5C5C"/>
+                </a:solidFill>
+              </a:defRPr>
+            </a:pPr>
+            <a:r>
+              <a:t>• Proposes approach, asks questions</a:t>
+            </a:r>
+          </a:p>
+          <a:p>
+            <a:pPr>
+              <a:defRPr sz="1300" b="0">
+                <a:solidFill>
+                  <a:srgbClr val="5C5C5C"/>
+                </a:solidFill>
+              </a:defRPr>
+            </a:pPr>
+            <a:r>
+              <a:t>• No edits until plan is approved</a:t>
+            </a:r>
+          </a:p>
+          <a:p>
+            <a:pPr>
+              <a:defRPr sz="1300" b="0">
+                <a:solidFill>
+                  <a:srgbClr val="5C5C5C"/>
+                </a:solidFill>
+              </a:defRPr>
+            </a:pPr>
+            <a:r>
+              <a:t>• Ensures alignment before effort</a:t>
+            </a:r>
+          </a:p>
+          <a:p>
+            <a:pPr>
+              <a:defRPr sz="600" b="0">
+                <a:solidFill>
+                  <a:srgbClr val="5C5C5C"/>
+                </a:solidFill>
+              </a:defRPr>
+            </a:pPr>
+          </a:p>
+          <a:p>
+            <a:pPr>
+              <a:defRPr sz="1400" b="1">
+                <a:solidFill>
+                  <a:srgbClr val="2B2B2B"/>
+                </a:solidFill>
+              </a:defRPr>
+            </a:pPr>
+            <a:r>
+              <a:t>Then implementation:</a:t>
+            </a:r>
+          </a:p>
+          <a:p>
+            <a:pPr>
+              <a:defRPr sz="1300" b="0">
+                <a:solidFill>
+                  <a:srgbClr val="5C5C5C"/>
+                </a:solidFill>
+              </a:defRPr>
+            </a:pPr>
+            <a:r>
+              <a:t>• Writes code across files</a:t>
+            </a:r>
+          </a:p>
+          <a:p>
+            <a:pPr>
+              <a:defRPr sz="1300" b="0">
+                <a:solidFill>
+                  <a:srgbClr val="5C5C5C"/>
+                </a:solidFill>
+              </a:defRPr>
+            </a:pPr>
+            <a:r>
+              <a:t>• Responds to feedback/review</a:t>
+            </a:r>
+          </a:p>
+          <a:p>
+            <a:pPr>
+              <a:defRPr sz="1300" b="0">
+                <a:solidFill>
+                  <a:srgbClr val="5C5C5C"/>
+                </a:solidFill>
+              </a:defRPr>
+            </a:pPr>
+            <a:r>
+              <a:t>• Documents progress</a:t>
+            </a:r>
+          </a:p>
+          <a:p>
+            <a:pPr>
+              <a:defRPr sz="600" b="0">
+                <a:solidFill>
+                  <a:srgbClr val="5C5C5C"/>
+                </a:solidFill>
+              </a:defRPr>
+            </a:pPr>
+          </a:p>
+          <a:p>
+            <a:pPr>
+              <a:defRPr sz="1300" b="1">
+                <a:solidFill>
+                  <a:srgbClr val="2B2B2B"/>
+                </a:solidFill>
+              </a:defRPr>
+            </a:pPr>
+            <a:r>
+              <a:t>~30 min interaction → ~1 day of work</a:t>
             </a:r>
           </a:p>
         </p:txBody>
@@ -41487,11 +41567,13 @@
         </p:nvSpPr>
         <p:spPr>
           <a:xfrm>
-            <a:off x="6000000" y="1600000"/>
-            <a:ext cx="5400000" cy="4600000"/>
+            <a:off x="5600000" y="1200000"/>
+            <a:ext cx="5800000" cy="5300000"/>
           </a:xfrm>
           <a:prstGeom prst="roundRect">
-            <a:avLst/>
+            <a:avLst>
+              <a:gd name="adj" fmla="val 2000"/>
+            </a:avLst>
           </a:prstGeom>
           <a:solidFill>
             <a:srgbClr val="1E1E2E"/>
@@ -41529,7 +41611,20 @@
               </a:defRPr>
             </a:pPr>
             <a:r>
-              <a:t>── claude ──</a:t>
+              <a:t>── claude (VSCode extension) ──</a:t>
+            </a:r>
+          </a:p>
+          <a:p>
+            <a:pPr>
+              <a:defRPr sz="1000">
+                <a:solidFill>
+                  <a:srgbClr val="D4D4D4"/>
+                </a:solidFill>
+                <a:latin typeface="Courier New"/>
+              </a:defRPr>
+            </a:pPr>
+            <a:r>
+              <a:t>                    ┌ Plan Mode ┐</a:t>
             </a:r>
           </a:p>
           <a:p>
@@ -41770,7 +41865,7 @@
               </a:defRPr>
             </a:pPr>
             <a:r>
-              <a:t>  Agent(Explore): existing FP infrastructure</a:t>
+              <a:t>  ⟳ Agent(Explore): existing FP infra</a:t>
             </a:r>
           </a:p>
           <a:p>
@@ -41783,7 +41878,7 @@
               </a:defRPr>
             </a:pPr>
             <a:r>
-              <a:t>  Agent(Explore): target and data path</a:t>
+              <a:t>  ⟳ Agent(Explore): target and data path</a:t>
             </a:r>
           </a:p>
           <a:p>
@@ -41796,7 +41891,7 @@
               </a:defRPr>
             </a:pPr>
             <a:r>
-              <a:t>  Agent(Explore): PID state and RAM usage</a:t>
+              <a:t>  ⟳ Agent(Explore): PID state and RAM usage</a:t>
             </a:r>
           </a:p>
           <a:p>
@@ -41832,7 +41927,56 @@
               </a:defRPr>
             </a:pPr>
             <a:r>
-              <a:t>BiquadFilter.vhd demonstrates the pattern...</a:t>
+              <a:t>8 instances of AdcDsp in DataPath.vhd,</a:t>
+            </a:r>
+          </a:p>
+          <a:p>
+            <a:pPr>
+              <a:defRPr sz="1000">
+                <a:solidFill>
+                  <a:srgbClr val="D4D4D4"/>
+                </a:solidFill>
+                <a:latin typeface="Courier New"/>
+              </a:defRPr>
+            </a:pPr>
+            <a:r>
+              <a:t>BiquadFilter.vhd demonstrates the pattern.</a:t>
+            </a:r>
+          </a:p>
+          <a:p>
+            <a:pPr>
+              <a:defRPr sz="1000">
+                <a:solidFill>
+                  <a:srgbClr val="D4D4D4"/>
+                </a:solidFill>
+                <a:latin typeface="Courier New"/>
+              </a:defRPr>
+            </a:pPr>
+            <a:r>
+              <a:t>DSP48: 8% used, BRAM: 59%, Slices: 75%.</a:t>
+            </a:r>
+          </a:p>
+          <a:p>
+            <a:pPr>
+              <a:defRPr sz="1000">
+                <a:solidFill>
+                  <a:srgbClr val="D4D4D4"/>
+                </a:solidFill>
+                <a:latin typeface="Courier New"/>
+              </a:defRPr>
+            </a:pPr>
+          </a:p>
+          <a:p>
+            <a:pPr>
+              <a:defRPr sz="1000">
+                <a:solidFill>
+                  <a:srgbClr val="D4D4D4"/>
+                </a:solidFill>
+                <a:latin typeface="Courier New"/>
+              </a:defRPr>
+            </a:pPr>
+            <a:r>
+              <a:t>Writing plan to docs/plans/fp-dsp-pid/...</a:t>
             </a:r>
           </a:p>
         </p:txBody>
@@ -42120,7 +42264,9 @@
             <a:ext cx="6500000" cy="4800000"/>
           </a:xfrm>
           <a:prstGeom prst="roundRect">
-            <a:avLst/>
+            <a:avLst>
+              <a:gd name="adj" fmla="val 2000"/>
+            </a:avLst>
           </a:prstGeom>
           <a:solidFill>
             <a:srgbClr val="1E1E2E"/>
@@ -42824,7 +42970,9 @@
             <a:ext cx="6200000" cy="4800000"/>
           </a:xfrm>
           <a:prstGeom prst="roundRect">
-            <a:avLst/>
+            <a:avLst>
+              <a:gd name="adj" fmla="val 2000"/>
+            </a:avLst>
           </a:prstGeom>
           <a:solidFill>
             <a:srgbClr val="1E1E2E"/>
@@ -43333,7 +43481,7 @@
         <p:spPr>
           <a:xfrm>
             <a:off x="548640" y="1600000"/>
-            <a:ext cx="5800000" cy="5000000"/>
+            <a:ext cx="5500000" cy="5000000"/>
           </a:xfrm>
           <a:prstGeom prst="rect">
             <a:avLst/>
@@ -43511,11 +43659,13 @@
         </p:nvSpPr>
         <p:spPr>
           <a:xfrm>
-            <a:off x="6600000" y="1600000"/>
-            <a:ext cx="4800000" cy="4600000"/>
+            <a:off x="6200000" y="1200000"/>
+            <a:ext cx="5200000" cy="5300000"/>
           </a:xfrm>
           <a:prstGeom prst="roundRect">
-            <a:avLst/>
+            <a:avLst>
+              <a:gd name="adj" fmla="val 2000"/>
+            </a:avLst>
           </a:prstGeom>
           <a:solidFill>
             <a:srgbClr val="1E1E2E"/>
@@ -43541,56 +43691,371 @@
           </a:fontRef>
         </p:style>
         <p:txBody>
-          <a:bodyPr rtlCol="0" anchor="ctr" wrap="square" lIns="150000" tIns="100000"/>
+          <a:bodyPr rtlCol="0" anchor="ctr" wrap="square" lIns="150000" tIns="100000" rIns="150000"/>
           <a:lstStyle/>
           <a:p>
             <a:pPr algn="ctr">
-              <a:defRPr sz="1000">
-                <a:solidFill>
-                  <a:srgbClr val="4EC9B0"/>
+              <a:defRPr sz="900">
+                <a:solidFill>
+                  <a:srgbClr val="888899"/>
                 </a:solidFill>
                 <a:latin typeface="Courier New"/>
               </a:defRPr>
             </a:pPr>
             <a:r>
-              <a:t>[Screenshot: Plan mode Q&amp;A in terminal]</a:t>
+              <a:t>── claude (plan mode Q&amp;A) ──</a:t>
             </a:r>
-            <a:br/>
-            <a:br/>
+          </a:p>
+          <a:p>
+            <a:pPr>
+              <a:defRPr sz="1000">
+                <a:solidFill>
+                  <a:srgbClr val="D4D4D4"/>
+                </a:solidFill>
+                <a:latin typeface="Courier New"/>
+              </a:defRPr>
+            </a:pPr>
             <a:r>
-              <a:t>┌ Question ─────────────────────────┐</a:t>
+              <a:t>┌ Question ────────────────────────────┐</a:t>
             </a:r>
-            <a:br/>
+          </a:p>
+          <a:p>
+            <a:pPr>
+              <a:defRPr sz="1000">
+                <a:solidFill>
+                  <a:srgbClr val="D4D4D4"/>
+                </a:solidFill>
+                <a:latin typeface="Courier New"/>
+              </a:defRPr>
+            </a:pPr>
             <a:r>
-              <a:t>│ Should we create a new module      │</a:t>
+              <a:t>│ For the floating point PID, should   │</a:t>
             </a:r>
-            <a:br/>
+          </a:p>
+          <a:p>
+            <a:pPr>
+              <a:defRPr sz="1000">
+                <a:solidFill>
+                  <a:srgbClr val="D4D4D4"/>
+                </a:solidFill>
+                <a:latin typeface="Courier New"/>
+              </a:defRPr>
+            </a:pPr>
             <a:r>
-              <a:t>│ (AdcDspFp.vhd) or modify AdcDsp   │</a:t>
+              <a:t>│ we create a new module or modify     │</a:t>
             </a:r>
-            <a:br/>
+          </a:p>
+          <a:p>
+            <a:pPr>
+              <a:defRPr sz="1000">
+                <a:solidFill>
+                  <a:srgbClr val="D4D4D4"/>
+                </a:solidFill>
+                <a:latin typeface="Courier New"/>
+              </a:defRPr>
+            </a:pPr>
             <a:r>
-              <a:t>│ in place?                          │</a:t>
+              <a:t>│ AdcDsp.vhd in place?                 │</a:t>
             </a:r>
-            <a:br/>
+          </a:p>
+          <a:p>
+            <a:pPr>
+              <a:defRPr sz="1000">
+                <a:solidFill>
+                  <a:srgbClr val="D4D4D4"/>
+                </a:solidFill>
+                <a:latin typeface="Courier New"/>
+              </a:defRPr>
+            </a:pPr>
             <a:r>
-              <a:t>│                                    │</a:t>
+              <a:t>│                                      │</a:t>
             </a:r>
-            <a:br/>
+          </a:p>
+          <a:p>
+            <a:pPr>
+              <a:defRPr sz="1000">
+                <a:solidFill>
+                  <a:srgbClr val="D4D4D4"/>
+                </a:solidFill>
+                <a:latin typeface="Courier New"/>
+              </a:defRPr>
+            </a:pPr>
             <a:r>
-              <a:t>│ ● New module (AdcDspFp.vhd)        │</a:t>
+              <a:t>│ ● New module (AdcDspFp.vhd)          │</a:t>
             </a:r>
-            <a:br/>
+          </a:p>
+          <a:p>
+            <a:pPr>
+              <a:defRPr sz="1000">
+                <a:solidFill>
+                  <a:srgbClr val="D4D4D4"/>
+                </a:solidFill>
+                <a:latin typeface="Courier New"/>
+              </a:defRPr>
+            </a:pPr>
             <a:r>
-              <a:t>│ ○ Modify in place with generic     │</a:t>
+              <a:t>│ ○ Modify in place with generic       │</a:t>
             </a:r>
-            <a:br/>
+          </a:p>
+          <a:p>
+            <a:pPr>
+              <a:defRPr sz="1000">
+                <a:solidFill>
+                  <a:srgbClr val="D4D4D4"/>
+                </a:solidFill>
+                <a:latin typeface="Courier New"/>
+              </a:defRPr>
+            </a:pPr>
             <a:r>
-              <a:t>│ ○ Modify in place, replace         │</a:t>
+              <a:t>│ ○ Modify in place, replace           │</a:t>
             </a:r>
-            <a:br/>
+          </a:p>
+          <a:p>
+            <a:pPr>
+              <a:defRPr sz="1000">
+                <a:solidFill>
+                  <a:srgbClr val="D4D4D4"/>
+                </a:solidFill>
+                <a:latin typeface="Courier New"/>
+              </a:defRPr>
+            </a:pPr>
             <a:r>
-              <a:t>└────────────────────────────────────┘</a:t>
+              <a:t>└────────────────────────────────────────┘</a:t>
+            </a:r>
+          </a:p>
+          <a:p>
+            <a:pPr>
+              <a:defRPr sz="1000">
+                <a:solidFill>
+                  <a:srgbClr val="D4D4D4"/>
+                </a:solidFill>
+                <a:latin typeface="Courier New"/>
+              </a:defRPr>
+            </a:pPr>
+          </a:p>
+          <a:p>
+            <a:pPr>
+              <a:defRPr sz="1000">
+                <a:solidFill>
+                  <a:srgbClr val="D4D4D4"/>
+                </a:solidFill>
+                <a:latin typeface="Courier New"/>
+              </a:defRPr>
+            </a:pPr>
+            <a:r>
+              <a:t>╭──────────────────────────────────────╮</a:t>
+            </a:r>
+          </a:p>
+          <a:p>
+            <a:pPr>
+              <a:defRPr sz="1000">
+                <a:solidFill>
+                  <a:srgbClr val="D4D4D4"/>
+                </a:solidFill>
+                <a:latin typeface="Courier New"/>
+              </a:defRPr>
+            </a:pPr>
+            <a:r>
+              <a:t>│ &gt; Can we pass the FP PID results     │</a:t>
+            </a:r>
+          </a:p>
+          <a:p>
+            <a:pPr>
+              <a:defRPr sz="1000">
+                <a:solidFill>
+                  <a:srgbClr val="D4D4D4"/>
+                </a:solidFill>
+                <a:latin typeface="Courier New"/>
+              </a:defRPr>
+            </a:pPr>
+            <a:r>
+              <a:t>│   directly to the biquad filter?     │</a:t>
+            </a:r>
+          </a:p>
+          <a:p>
+            <a:pPr>
+              <a:defRPr sz="1000">
+                <a:solidFill>
+                  <a:srgbClr val="D4D4D4"/>
+                </a:solidFill>
+                <a:latin typeface="Courier New"/>
+              </a:defRPr>
+            </a:pPr>
+            <a:r>
+              <a:t>╰──────────────────────────────────────╯</a:t>
+            </a:r>
+          </a:p>
+          <a:p>
+            <a:pPr>
+              <a:defRPr sz="1000">
+                <a:solidFill>
+                  <a:srgbClr val="D4D4D4"/>
+                </a:solidFill>
+                <a:latin typeface="Courier New"/>
+              </a:defRPr>
+            </a:pPr>
+          </a:p>
+          <a:p>
+            <a:pPr>
+              <a:defRPr sz="1000">
+                <a:solidFill>
+                  <a:srgbClr val="D4D4D4"/>
+                </a:solidFill>
+                <a:latin typeface="Courier New"/>
+              </a:defRPr>
+            </a:pPr>
+            <a:r>
+              <a:t>Yes — add INPUT_IS_FLOAT_G generic to</a:t>
+            </a:r>
+          </a:p>
+          <a:p>
+            <a:pPr>
+              <a:defRPr sz="1000">
+                <a:solidFill>
+                  <a:srgbClr val="D4D4D4"/>
+                </a:solidFill>
+                <a:latin typeface="Courier New"/>
+              </a:defRPr>
+            </a:pPr>
+            <a:r>
+              <a:t>BiquadFilter. Skip its Int2Fp stage.</a:t>
+            </a:r>
+          </a:p>
+          <a:p>
+            <a:pPr>
+              <a:defRPr sz="1000">
+                <a:solidFill>
+                  <a:srgbClr val="D4D4D4"/>
+                </a:solidFill>
+                <a:latin typeface="Courier New"/>
+              </a:defRPr>
+            </a:pPr>
+            <a:r>
+              <a:t>Eliminates 8 redundant IP instances.</a:t>
+            </a:r>
+          </a:p>
+          <a:p>
+            <a:pPr>
+              <a:defRPr sz="1000">
+                <a:solidFill>
+                  <a:srgbClr val="D4D4D4"/>
+                </a:solidFill>
+                <a:latin typeface="Courier New"/>
+              </a:defRPr>
+            </a:pPr>
+          </a:p>
+          <a:p>
+            <a:pPr>
+              <a:defRPr sz="1000">
+                <a:solidFill>
+                  <a:srgbClr val="D4D4D4"/>
+                </a:solidFill>
+                <a:latin typeface="Courier New"/>
+              </a:defRPr>
+            </a:pPr>
+            <a:r>
+              <a:t>╭──────────────────────────────────────╮</a:t>
+            </a:r>
+          </a:p>
+          <a:p>
+            <a:pPr>
+              <a:defRPr sz="1000">
+                <a:solidFill>
+                  <a:srgbClr val="D4D4D4"/>
+                </a:solidFill>
+                <a:latin typeface="Courier New"/>
+              </a:defRPr>
+            </a:pPr>
+            <a:r>
+              <a:t>│ &gt; Is it possible to have a jump of   │</a:t>
+            </a:r>
+          </a:p>
+          <a:p>
+            <a:pPr>
+              <a:defRPr sz="1000">
+                <a:solidFill>
+                  <a:srgbClr val="D4D4D4"/>
+                </a:solidFill>
+                <a:latin typeface="Courier New"/>
+              </a:defRPr>
+            </a:pPr>
+            <a:r>
+              <a:t>│   more than 1 flux quantum? Can we   │</a:t>
+            </a:r>
+          </a:p>
+          <a:p>
+            <a:pPr>
+              <a:defRPr sz="1000">
+                <a:solidFill>
+                  <a:srgbClr val="D4D4D4"/>
+                </a:solidFill>
+                <a:latin typeface="Courier New"/>
+              </a:defRPr>
+            </a:pPr>
+            <a:r>
+              <a:t>│   support this now with FP range?    │</a:t>
+            </a:r>
+          </a:p>
+          <a:p>
+            <a:pPr>
+              <a:defRPr sz="1000">
+                <a:solidFill>
+                  <a:srgbClr val="D4D4D4"/>
+                </a:solidFill>
+                <a:latin typeface="Courier New"/>
+              </a:defRPr>
+            </a:pPr>
+            <a:r>
+              <a:t>╰──────────────────────────────────────╯</a:t>
+            </a:r>
+          </a:p>
+          <a:p>
+            <a:pPr>
+              <a:defRPr sz="1000">
+                <a:solidFill>
+                  <a:srgbClr val="D4D4D4"/>
+                </a:solidFill>
+                <a:latin typeface="Courier New"/>
+              </a:defRPr>
+            </a:pPr>
+          </a:p>
+          <a:p>
+            <a:pPr>
+              <a:defRPr sz="1000">
+                <a:solidFill>
+                  <a:srgbClr val="D4D4D4"/>
+                </a:solidFill>
+                <a:latin typeface="Courier New"/>
+              </a:defRPr>
+            </a:pPr>
+            <a:r>
+              <a:t>Yes — iterative integer loop. Each iter</a:t>
+            </a:r>
+          </a:p>
+          <a:p>
+            <a:pPr>
+              <a:defRPr sz="1000">
+                <a:solidFill>
+                  <a:srgbClr val="D4D4D4"/>
+                </a:solidFill>
+                <a:latin typeface="Courier New"/>
+              </a:defRPr>
+            </a:pPr>
+            <a:r>
+              <a:t>costs 1 cycle. Bounded by DAC range /</a:t>
+            </a:r>
+          </a:p>
+          <a:p>
+            <a:pPr>
+              <a:defRPr sz="1000">
+                <a:solidFill>
+                  <a:srgbClr val="D4D4D4"/>
+                </a:solidFill>
+                <a:latin typeface="Courier New"/>
+              </a:defRPr>
+            </a:pPr>
+            <a:r>
+              <a:t>fluxQuantum ≈ 4-8 iterations max.</a:t>
             </a:r>
           </a:p>
         </p:txBody>
@@ -44041,7 +44506,9 @@
             <a:ext cx="5600000" cy="4800000"/>
           </a:xfrm>
           <a:prstGeom prst="roundRect">
-            <a:avLst/>
+            <a:avLst>
+              <a:gd name="adj" fmla="val 2000"/>
+            </a:avLst>
           </a:prstGeom>
           <a:solidFill>
             <a:srgbClr val="1E1E2E"/>
@@ -44707,10 +45174,12 @@
         <p:spPr>
           <a:xfrm>
             <a:off x="6300000" y="1200000"/>
-            <a:ext cx="5100000" cy="4000000"/>
+            <a:ext cx="5100000" cy="5200000"/>
           </a:xfrm>
           <a:prstGeom prst="roundRect">
-            <a:avLst/>
+            <a:avLst>
+              <a:gd name="adj" fmla="val 2000"/>
+            </a:avLst>
           </a:prstGeom>
           <a:solidFill>
             <a:srgbClr val="1E1E2E"/>
@@ -44748,7 +45217,7 @@
               </a:defRPr>
             </a:pPr>
             <a:r>
-              <a:t>── claude ──</a:t>
+              <a:t>── claude (review &amp; iteration) ──</a:t>
             </a:r>
           </a:p>
           <a:p>
@@ -44861,68 +45330,6 @@
                 <a:latin typeface="Courier New"/>
               </a:defRPr>
             </a:pPr>
-            <a:r>
-              <a:t>In the original, all three use the</a:t>
-            </a:r>
-          </a:p>
-          <a:p>
-            <a:pPr>
-              <a:defRPr sz="1000">
-                <a:solidFill>
-                  <a:srgbClr val="D4D4D4"/>
-                </a:solidFill>
-                <a:latin typeface="Courier New"/>
-              </a:defRPr>
-            </a:pPr>
-            <a:r>
-              <a:t>Raw/Link pattern...</a:t>
-            </a:r>
-          </a:p>
-          <a:p>
-            <a:pPr>
-              <a:defRPr sz="1000">
-                <a:solidFill>
-                  <a:srgbClr val="D4D4D4"/>
-                </a:solidFill>
-                <a:latin typeface="Courier New"/>
-              </a:defRPr>
-            </a:pPr>
-          </a:p>
-          <a:p>
-            <a:pPr>
-              <a:defRPr sz="1000">
-                <a:solidFill>
-                  <a:srgbClr val="D4D4D4"/>
-                </a:solidFill>
-                <a:latin typeface="Courier New"/>
-              </a:defRPr>
-            </a:pPr>
-            <a:r>
-              <a:t>Should I add Raw/Link for all three</a:t>
-            </a:r>
-          </a:p>
-          <a:p>
-            <a:pPr>
-              <a:defRPr sz="1000">
-                <a:solidFill>
-                  <a:srgbClr val="D4D4D4"/>
-                </a:solidFill>
-                <a:latin typeface="Courier New"/>
-              </a:defRPr>
-            </a:pPr>
-            <a:r>
-              <a:t>for consistency?</a:t>
-            </a:r>
-          </a:p>
-          <a:p>
-            <a:pPr>
-              <a:defRPr sz="1000">
-                <a:solidFill>
-                  <a:srgbClr val="D4D4D4"/>
-                </a:solidFill>
-                <a:latin typeface="Courier New"/>
-              </a:defRPr>
-            </a:pPr>
           </a:p>
           <a:p>
             <a:pPr>
@@ -44970,8 +45377,119 @@
               </a:defRPr>
             </a:pPr>
             <a:r>
-              <a:t>───────────────────────────────────────</a:t>
+              <a:t>╭─────────────────────────────────────╮</a:t>
             </a:r>
+          </a:p>
+          <a:p>
+            <a:pPr>
+              <a:defRPr sz="1000">
+                <a:solidFill>
+                  <a:srgbClr val="D4D4D4"/>
+                </a:solidFill>
+                <a:latin typeface="Courier New"/>
+              </a:defRPr>
+            </a:pPr>
+            <a:r>
+              <a:t>│ &gt; There should be just one non-     │</a:t>
+            </a:r>
+          </a:p>
+          <a:p>
+            <a:pPr>
+              <a:defRPr sz="1000">
+                <a:solidFill>
+                  <a:srgbClr val="D4D4D4"/>
+                </a:solidFill>
+                <a:latin typeface="Courier New"/>
+              </a:defRPr>
+            </a:pPr>
+            <a:r>
+              <a:t>│   hidden FluxQuantum LinkVariable.  │</a:t>
+            </a:r>
+          </a:p>
+          <a:p>
+            <a:pPr>
+              <a:defRPr sz="1000">
+                <a:solidFill>
+                  <a:srgbClr val="D4D4D4"/>
+                </a:solidFill>
+                <a:latin typeface="Courier New"/>
+              </a:defRPr>
+            </a:pPr>
+            <a:r>
+              <a:t>│   It should set all raw registers.  │</a:t>
+            </a:r>
+          </a:p>
+          <a:p>
+            <a:pPr>
+              <a:defRPr sz="1000">
+                <a:solidFill>
+                  <a:srgbClr val="D4D4D4"/>
+                </a:solidFill>
+                <a:latin typeface="Courier New"/>
+              </a:defRPr>
+            </a:pPr>
+            <a:r>
+              <a:t>╰─────────────────────────────────────╯</a:t>
+            </a:r>
+          </a:p>
+          <a:p>
+            <a:pPr>
+              <a:defRPr sz="1000">
+                <a:solidFill>
+                  <a:srgbClr val="D4D4D4"/>
+                </a:solidFill>
+                <a:latin typeface="Courier New"/>
+              </a:defRPr>
+            </a:pPr>
+          </a:p>
+          <a:p>
+            <a:pPr>
+              <a:defRPr sz="1000">
+                <a:solidFill>
+                  <a:srgbClr val="D4D4D4"/>
+                </a:solidFill>
+                <a:latin typeface="Courier New"/>
+              </a:defRPr>
+            </a:pPr>
+            <a:r>
+              <a:t>Done. FluxQuantum LinkVariable now sets</a:t>
+            </a:r>
+          </a:p>
+          <a:p>
+            <a:pPr>
+              <a:defRPr sz="1000">
+                <a:solidFill>
+                  <a:srgbClr val="D4D4D4"/>
+                </a:solidFill>
+                <a:latin typeface="Courier New"/>
+              </a:defRPr>
+            </a:pPr>
+            <a:r>
+              <a:t>FluxQuantumIntRaw, FluxQuantumFpRaw,</a:t>
+            </a:r>
+          </a:p>
+          <a:p>
+            <a:pPr>
+              <a:defRPr sz="1000">
+                <a:solidFill>
+                  <a:srgbClr val="D4D4D4"/>
+                </a:solidFill>
+                <a:latin typeface="Courier New"/>
+              </a:defRPr>
+            </a:pPr>
+            <a:r>
+              <a:t>and InvFluxQuantumFpRaw internally.</a:t>
+            </a:r>
+          </a:p>
+          <a:p>
+            <a:pPr>
+              <a:defRPr sz="1000">
+                <a:solidFill>
+                  <a:srgbClr val="D4D4D4"/>
+                </a:solidFill>
+                <a:latin typeface="Courier New"/>
+              </a:defRPr>
+            </a:pPr>
           </a:p>
           <a:p>
             <a:pPr>
@@ -44996,7 +45514,7 @@
               </a:defRPr>
             </a:pPr>
             <a:r>
-              <a:t>│ &gt; There should be just one non-     │</a:t>
+              <a:t>│ &gt; Make sure the software is also    │</a:t>
             </a:r>
           </a:p>
           <a:p>
@@ -45009,7 +45527,7 @@
               </a:defRPr>
             </a:pPr>
             <a:r>
-              <a:t>│   hidden FluxQuantum LinkVariable.  │</a:t>
+              <a:t>│   updated to instantiate the new    │</a:t>
             </a:r>
           </a:p>
           <a:p>
@@ -45022,7 +45540,7 @@
               </a:defRPr>
             </a:pPr>
             <a:r>
-              <a:t>│   It should set all raw registers.  │</a:t>
+              <a:t>│   AdcDspFp device. There should be  │</a:t>
             </a:r>
           </a:p>
           <a:p>
@@ -45035,7 +45553,82 @@
               </a:defRPr>
             </a:pPr>
             <a:r>
+              <a:t>│   a CLI arg to select FP version.   │</a:t>
+            </a:r>
+          </a:p>
+          <a:p>
+            <a:pPr>
+              <a:defRPr sz="1000">
+                <a:solidFill>
+                  <a:srgbClr val="D4D4D4"/>
+                </a:solidFill>
+                <a:latin typeface="Courier New"/>
+              </a:defRPr>
+            </a:pPr>
+            <a:r>
               <a:t>╰─────────────────────────────────────╯</a:t>
+            </a:r>
+          </a:p>
+          <a:p>
+            <a:pPr>
+              <a:defRPr sz="1000">
+                <a:solidFill>
+                  <a:srgbClr val="D4D4D4"/>
+                </a:solidFill>
+                <a:latin typeface="Courier New"/>
+              </a:defRPr>
+            </a:pPr>
+          </a:p>
+          <a:p>
+            <a:pPr>
+              <a:defRPr sz="1000">
+                <a:solidFill>
+                  <a:srgbClr val="D4D4D4"/>
+                </a:solidFill>
+                <a:latin typeface="Courier New"/>
+              </a:defRPr>
+            </a:pPr>
+            <a:r>
+              <a:t>Threaded --floatPid through:</a:t>
+            </a:r>
+          </a:p>
+          <a:p>
+            <a:pPr>
+              <a:defRPr sz="1000">
+                <a:solidFill>
+                  <a:srgbClr val="D4D4D4"/>
+                </a:solidFill>
+                <a:latin typeface="Courier New"/>
+              </a:defRPr>
+            </a:pPr>
+            <a:r>
+              <a:t>ArgParser → GroupRoot → Group →</a:t>
+            </a:r>
+          </a:p>
+          <a:p>
+            <a:pPr>
+              <a:defRPr sz="1000">
+                <a:solidFill>
+                  <a:srgbClr val="D4D4D4"/>
+                </a:solidFill>
+                <a:latin typeface="Courier New"/>
+              </a:defRPr>
+            </a:pPr>
+            <a:r>
+              <a:t>HardwareGroup → ColumnFpgaBoard →</a:t>
+            </a:r>
+          </a:p>
+          <a:p>
+            <a:pPr>
+              <a:defRPr sz="1000">
+                <a:solidFill>
+                  <a:srgbClr val="D4D4D4"/>
+                </a:solidFill>
+                <a:latin typeface="Courier New"/>
+              </a:defRPr>
+            </a:pPr>
+            <a:r>
+              <a:t>DataPath (selects AdcDspFp vs AdcDsp)</a:t>
             </a:r>
           </a:p>
         </p:txBody>
@@ -45048,8 +45641,8 @@
         </p:nvSpPr>
         <p:spPr>
           <a:xfrm>
-            <a:off x="6300000" y="5400000"/>
-            <a:ext cx="5100000" cy="5000000"/>
+            <a:off x="548640" y="5300000"/>
+            <a:ext cx="5500000" cy="5000000"/>
           </a:xfrm>
           <a:prstGeom prst="rect">
             <a:avLst/>
@@ -45063,50 +45656,71 @@
           <a:lstStyle/>
           <a:p>
             <a:pPr>
-              <a:defRPr sz="1100" b="0">
+              <a:defRPr sz="400" b="0">
                 <a:solidFill>
                   <a:srgbClr val="5C5C5C"/>
+                </a:solidFill>
+              </a:defRPr>
+            </a:pPr>
+          </a:p>
+          <a:p>
+            <a:pPr>
+              <a:defRPr sz="1200" b="1">
+                <a:solidFill>
+                  <a:srgbClr val="2B2B2B"/>
                 </a:solidFill>
               </a:defRPr>
             </a:pPr>
             <a:r>
-              <a:t>Note: The software side was underspecified</a:t>
+              <a:t>Note: Software side was underspecified</a:t>
             </a:r>
           </a:p>
           <a:p>
             <a:pPr>
-              <a:defRPr sz="1100" b="0">
+              <a:defRPr sz="1200" b="0">
                 <a:solidFill>
                   <a:srgbClr val="5C5C5C"/>
                 </a:solidFill>
               </a:defRPr>
             </a:pPr>
             <a:r>
-              <a:t>in the original prompt and plan. Additional</a:t>
+              <a:t>in the original prompt and plan —</a:t>
             </a:r>
           </a:p>
           <a:p>
             <a:pPr>
-              <a:defRPr sz="1100" b="0">
+              <a:defRPr sz="1200" b="0">
                 <a:solidFill>
                   <a:srgbClr val="5C5C5C"/>
                 </a:solidFill>
               </a:defRPr>
             </a:pPr>
             <a:r>
-              <a:t>prompting was needed to generate the Python</a:t>
+              <a:t>additional prompting rounds were needed</a:t>
             </a:r>
           </a:p>
           <a:p>
             <a:pPr>
-              <a:defRPr sz="1100" b="0">
+              <a:defRPr sz="1200" b="0">
                 <a:solidFill>
                   <a:srgbClr val="5C5C5C"/>
                 </a:solidFill>
               </a:defRPr>
             </a:pPr>
             <a:r>
-              <a:t>drivers and CLI integration correctly.</a:t>
+              <a:t>to get Python drivers and CLI flag</a:t>
+            </a:r>
+          </a:p>
+          <a:p>
+            <a:pPr>
+              <a:defRPr sz="1200" b="0">
+                <a:solidFill>
+                  <a:srgbClr val="5C5C5C"/>
+                </a:solidFill>
+              </a:defRPr>
+            </a:pPr>
+            <a:r>
+              <a:t>integration generated correctly.</a:t>
             </a:r>
           </a:p>
         </p:txBody>

</xml_diff>